<commit_message>
Lesson sd-10-013: describe each book in the lesson's own words instead of following the source list, with the figure, metadata and deck
Co-Authored-By: Claude Sonnet 5.5 <noreply@anthropic.com>
Claude-Session: https://claude.ai/code/session_011dmt3ZFdN8sjiTfDnyUVN7
</commit_message>
<xml_diff>
--- a/system-design-101/vi/lessons/sd-10-013/slides/sd-10-013.pptx
+++ b/system-design-101/vi/lessons/sd-10-013/slides/sd-10-013.pptx
@@ -2240,7 +2240,7 @@
               <a:buNone/>
             </a:pPr>
             <a:r>
-              <a:rPr lang="en-US" sz="6241" dirty="0" spc="-3" kern="0">
+              <a:rPr lang="en-US" sz="6241" dirty="0" spc="-5" kern="0">
                 <a:solidFill>
                   <a:srgbClr val="F3EEE3"/>
                 </a:solidFill>
@@ -2248,7 +2248,7 @@
                 <a:ea typeface="Bricolage Grotesque ExtraBold" pitchFamily="34" charset="-122"/>
                 <a:cs typeface="Bricolage Grotesque ExtraBold" pitchFamily="34" charset="-120"/>
               </a:rPr>
-              <a:t>1</a:t>
+              <a:t>0</a:t>
             </a:r>
             <a:endParaRPr lang="en-US" sz="6241" dirty="0"/>
           </a:p>
@@ -2279,7 +2279,7 @@
               <a:buNone/>
             </a:pPr>
             <a:r>
-              <a:rPr lang="en-US" sz="1800" dirty="0" spc="-3" kern="0">
+              <a:rPr lang="en-US" sz="1800" dirty="0" spc="-1" kern="0">
                 <a:solidFill>
                   <a:srgbClr val="9AA0B5"/>
                 </a:solidFill>
@@ -2287,10 +2287,10 @@
                 <a:ea typeface="Be Vietnam Pro" pitchFamily="34" charset="-122"/>
                 <a:cs typeface="Be Vietnam Pro" pitchFamily="34" charset="-120"/>
               </a:rPr>
-              <a:t>cuốn</a:t>
-            </a:r>
-            <a:r>
-              <a:rPr lang="en-US" sz="1800" dirty="0" spc="2" kern="0">
+              <a:t>thứ tự</a:t>
+            </a:r>
+            <a:r>
+              <a:rPr lang="en-US" sz="1800" dirty="0" spc="9" kern="0">
                 <a:solidFill>
                   <a:srgbClr val="9AA0B5"/>
                 </a:solidFill>
@@ -2298,10 +2298,10 @@
                 <a:ea typeface="Be Vietnam Pro" pitchFamily="34" charset="-122"/>
                 <a:cs typeface="Be Vietnam Pro" pitchFamily="34" charset="-120"/>
               </a:rPr>
-              <a:t> có</a:t>
-            </a:r>
-            <a:r>
-              <a:rPr lang="en-US" sz="1800" dirty="0" spc="-2" kern="0">
+              <a:t> đọc</a:t>
+            </a:r>
+            <a:r>
+              <a:rPr lang="en-US" sz="1800" dirty="0" spc="0" kern="0">
                 <a:solidFill>
                   <a:srgbClr val="9AA0B5"/>
                 </a:solidFill>
@@ -2309,18 +2309,7 @@
                 <a:ea typeface="Be Vietnam Pro" pitchFamily="34" charset="-122"/>
                 <a:cs typeface="Be Vietnam Pro" pitchFamily="34" charset="-120"/>
               </a:rPr>
-              <a:t> mô</a:t>
-            </a:r>
-            <a:r>
-              <a:rPr lang="en-US" sz="1800" dirty="0" spc="-13" kern="0">
-                <a:solidFill>
-                  <a:srgbClr val="9AA0B5"/>
-                </a:solidFill>
-                <a:latin typeface="Be Vietnam Pro" pitchFamily="34" charset="0"/>
-                <a:ea typeface="Be Vietnam Pro" pitchFamily="34" charset="-122"/>
-                <a:cs typeface="Be Vietnam Pro" pitchFamily="34" charset="-120"/>
-              </a:rPr>
-              <a:t> tả</a:t>
+              <a:t> nào</a:t>
             </a:r>
             <a:endParaRPr lang="en-US" sz="1800" dirty="0"/>
           </a:p>
@@ -3506,18 +3495,29 @@
               <a:buNone/>
             </a:pPr>
             <a:r>
-              <a:rPr lang="en-US" sz="2850" dirty="0" spc="-3" kern="0">
-                <a:solidFill>
-                  <a:srgbClr val="14161C"/>
-                </a:solidFill>
-                <a:latin typeface="Be Vietnam Pro" pitchFamily="34" charset="0"/>
-                <a:ea typeface="Be Vietnam Pro" pitchFamily="34" charset="-122"/>
-                <a:cs typeface="Be Vietnam Pro" pitchFamily="34" charset="-120"/>
-              </a:rPr>
-              <a:t>Nguồn</a:t>
-            </a:r>
-            <a:r>
-              <a:rPr lang="en-US" sz="2850" dirty="0" spc="-14" kern="0">
+              <a:rPr lang="en-US" sz="2850" dirty="0" spc="0" kern="0">
+                <a:solidFill>
+                  <a:srgbClr val="14161C"/>
+                </a:solidFill>
+                <a:latin typeface="Be Vietnam Pro" pitchFamily="34" charset="0"/>
+                <a:ea typeface="Be Vietnam Pro" pitchFamily="34" charset="-122"/>
+                <a:cs typeface="Be Vietnam Pro" pitchFamily="34" charset="-120"/>
+              </a:rPr>
+              <a:t>Danh</a:t>
+            </a:r>
+            <a:r>
+              <a:rPr lang="en-US" sz="2850" dirty="0" spc="-6" kern="0">
+                <a:solidFill>
+                  <a:srgbClr val="14161C"/>
+                </a:solidFill>
+                <a:latin typeface="Be Vietnam Pro" pitchFamily="34" charset="0"/>
+                <a:ea typeface="Be Vietnam Pro" pitchFamily="34" charset="-122"/>
+                <a:cs typeface="Be Vietnam Pro" pitchFamily="34" charset="-120"/>
+              </a:rPr>
+              <a:t> sách</a:t>
+            </a:r>
+            <a:r>
+              <a:rPr lang="en-US" sz="2850" dirty="0" spc="-15" kern="0">
                 <a:solidFill>
                   <a:srgbClr val="14161C"/>
                 </a:solidFill>
@@ -3528,7 +3528,7 @@
               <a:t> gợi</a:t>
             </a:r>
             <a:r>
-              <a:rPr lang="en-US" sz="2850" dirty="0" spc="1" kern="0">
+              <a:rPr lang="en-US" sz="2850" dirty="0" spc="2" kern="0">
                 <a:solidFill>
                   <a:srgbClr val="14161C"/>
                 </a:solidFill>
@@ -3613,7 +3613,18 @@
                 <a:ea typeface="Be Vietnam Pro" pitchFamily="34" charset="-122"/>
                 <a:cs typeface="Be Vietnam Pro" pitchFamily="34" charset="-120"/>
               </a:rPr>
-              <a:t> nhóm,</a:t>
+              <a:t> nhóm; mỗi cuốn</a:t>
+            </a:r>
+            <a:r>
+              <a:rPr lang="en-US" sz="2850" dirty="0" spc="-4" kern="0">
+                <a:solidFill>
+                  <a:srgbClr val="14161C"/>
+                </a:solidFill>
+                <a:latin typeface="Be Vietnam Pro" pitchFamily="34" charset="0"/>
+                <a:ea typeface="Be Vietnam Pro" pitchFamily="34" charset="-122"/>
+                <a:cs typeface="Be Vietnam Pro" pitchFamily="34" charset="-120"/>
+              </a:rPr>
+              <a:t> bàn</a:t>
             </a:r>
             <a:r>
               <a:rPr lang="en-US" sz="2850" dirty="0" spc="-17" kern="0">
@@ -3624,62 +3635,29 @@
                 <a:ea typeface="Be Vietnam Pro" pitchFamily="34" charset="-122"/>
                 <a:cs typeface="Be Vietnam Pro" pitchFamily="34" charset="-120"/>
               </a:rPr>
-              <a:t> và</a:t>
-            </a:r>
-            <a:r>
-              <a:rPr lang="en-US" sz="2850" dirty="0" spc="-15" kern="0">
-                <a:solidFill>
-                  <a:srgbClr val="14161C"/>
-                </a:solidFill>
-                <a:latin typeface="Be Vietnam Pro" pitchFamily="34" charset="0"/>
-                <a:ea typeface="Be Vietnam Pro" pitchFamily="34" charset="-122"/>
-                <a:cs typeface="Be Vietnam Pro" pitchFamily="34" charset="-120"/>
-              </a:rPr>
-              <a:t> gần</a:t>
-            </a:r>
-            <a:r>
-              <a:rPr lang="en-US" sz="2850" dirty="0" spc="1" kern="0">
-                <a:solidFill>
-                  <a:srgbClr val="14161C"/>
-                </a:solidFill>
-                <a:latin typeface="Be Vietnam Pro" pitchFamily="34" charset="0"/>
-                <a:ea typeface="Be Vietnam Pro" pitchFamily="34" charset="-122"/>
-                <a:cs typeface="Be Vietnam Pro" pitchFamily="34" charset="-120"/>
-              </a:rPr>
-              <a:t> như</a:t>
-            </a:r>
-            <a:r>
-              <a:rPr lang="en-US" sz="2850" dirty="0" spc="0" kern="0">
-                <a:solidFill>
-                  <a:srgbClr val="14161C"/>
-                </a:solidFill>
-                <a:latin typeface="Be Vietnam Pro" pitchFamily="34" charset="0"/>
-                <a:ea typeface="Be Vietnam Pro" pitchFamily="34" charset="-122"/>
-                <a:cs typeface="Be Vietnam Pro" pitchFamily="34" charset="-120"/>
-              </a:rPr>
-              <a:t> chỉ</a:t>
-            </a:r>
-            <a:r>
-              <a:rPr lang="en-US" sz="2850" dirty="0" spc="-5" kern="0">
-                <a:solidFill>
-                  <a:srgbClr val="14161C"/>
-                </a:solidFill>
-                <a:latin typeface="Be Vietnam Pro" pitchFamily="34" charset="0"/>
-                <a:ea typeface="Be Vietnam Pro" pitchFamily="34" charset="-122"/>
-                <a:cs typeface="Be Vietnam Pro" pitchFamily="34" charset="-120"/>
-              </a:rPr>
-              <a:t> liệt</a:t>
-            </a:r>
-            <a:r>
-              <a:rPr lang="en-US" sz="2850" dirty="0" spc="-32" kern="0">
-                <a:solidFill>
-                  <a:srgbClr val="14161C"/>
-                </a:solidFill>
-                <a:latin typeface="Be Vietnam Pro" pitchFamily="34" charset="0"/>
-                <a:ea typeface="Be Vietnam Pro" pitchFamily="34" charset="-122"/>
-                <a:cs typeface="Be Vietnam Pro" pitchFamily="34" charset="-120"/>
-              </a:rPr>
-              <a:t> kê.</a:t>
+              <a:t> về</a:t>
+            </a:r>
+            <a:r>
+              <a:rPr lang="en-US" sz="2850" dirty="0" spc="-9" kern="0">
+                <a:solidFill>
+                  <a:srgbClr val="14161C"/>
+                </a:solidFill>
+                <a:latin typeface="Be Vietnam Pro" pitchFamily="34" charset="0"/>
+                <a:ea typeface="Be Vietnam Pro" pitchFamily="34" charset="-122"/>
+                <a:cs typeface="Be Vietnam Pro" pitchFamily="34" charset="-120"/>
+              </a:rPr>
+              <a:t> một</a:t>
+            </a:r>
+            <a:r>
+              <a:rPr lang="en-US" sz="2850" dirty="0" spc="-1" kern="0">
+                <a:solidFill>
+                  <a:srgbClr val="14161C"/>
+                </a:solidFill>
+                <a:latin typeface="Be Vietnam Pro" pitchFamily="34" charset="0"/>
+                <a:ea typeface="Be Vietnam Pro" pitchFamily="34" charset="-122"/>
+                <a:cs typeface="Be Vietnam Pro" pitchFamily="34" charset="-120"/>
+              </a:rPr>
+              <a:t> việc.</a:t>
             </a:r>
             <a:endParaRPr lang="en-US" sz="2850" dirty="0"/>
           </a:p>
@@ -3889,7 +3867,7 @@
                 <a:ea typeface="Be Vietnam Pro" pitchFamily="34" charset="-122"/>
                 <a:cs typeface="Be Vietnam Pro" pitchFamily="34" charset="-120"/>
               </a:rPr>
-              <a:t> chỗ</a:t>
+              <a:t> mỗi</a:t>
             </a:r>
             <a:r>
               <a:rPr lang="en-US" sz="2550" dirty="0" spc="1" kern="0">
@@ -3900,51 +3878,51 @@
                 <a:ea typeface="Be Vietnam Pro" pitchFamily="34" charset="-122"/>
                 <a:cs typeface="Be Vietnam Pro" pitchFamily="34" charset="-120"/>
               </a:rPr>
-              <a:t> nguồn</a:t>
-            </a:r>
-            <a:r>
-              <a:rPr lang="en-US" sz="2550" dirty="0" spc="0" kern="0">
-                <a:solidFill>
-                  <a:srgbClr val="14161C"/>
-                </a:solidFill>
-                <a:latin typeface="Be Vietnam Pro" pitchFamily="34" charset="0"/>
-                <a:ea typeface="Be Vietnam Pro" pitchFamily="34" charset="-122"/>
-                <a:cs typeface="Be Vietnam Pro" pitchFamily="34" charset="-120"/>
-              </a:rPr>
-              <a:t> có</a:t>
-            </a:r>
-            <a:r>
-              <a:rPr lang="en-US" sz="2550" dirty="0" spc="-1" kern="0">
-                <a:solidFill>
-                  <a:srgbClr val="14161C"/>
-                </a:solidFill>
-                <a:latin typeface="Be Vietnam Pro" pitchFamily="34" charset="0"/>
-                <a:ea typeface="Be Vietnam Pro" pitchFamily="34" charset="-122"/>
-                <a:cs typeface="Be Vietnam Pro" pitchFamily="34" charset="-120"/>
-              </a:rPr>
-              <a:t> lời</a:t>
-            </a:r>
-            <a:r>
-              <a:rPr lang="en-US" sz="2550" dirty="0" spc="0" kern="0">
-                <a:solidFill>
-                  <a:srgbClr val="14161C"/>
-                </a:solidFill>
-                <a:latin typeface="Be Vietnam Pro" pitchFamily="34" charset="0"/>
-                <a:ea typeface="Be Vietnam Pro" pitchFamily="34" charset="-122"/>
-                <a:cs typeface="Be Vietnam Pro" pitchFamily="34" charset="-120"/>
-              </a:rPr>
-              <a:t> giải</a:t>
-            </a:r>
-            <a:r>
-              <a:rPr lang="en-US" sz="2550" dirty="0" spc="1" kern="0">
-                <a:solidFill>
-                  <a:srgbClr val="14161C"/>
-                </a:solidFill>
-                <a:latin typeface="Be Vietnam Pro" pitchFamily="34" charset="0"/>
-                <a:ea typeface="Be Vietnam Pro" pitchFamily="34" charset="-122"/>
-                <a:cs typeface="Be Vietnam Pro" pitchFamily="34" charset="-120"/>
-              </a:rPr>
-              <a:t> thích</a:t>
+              <a:t> cuốn</a:t>
+            </a:r>
+            <a:r>
+              <a:rPr lang="en-US" sz="2550" dirty="0" spc="-3" kern="0">
+                <a:solidFill>
+                  <a:srgbClr val="14161C"/>
+                </a:solidFill>
+                <a:latin typeface="Be Vietnam Pro" pitchFamily="34" charset="0"/>
+                <a:ea typeface="Be Vietnam Pro" pitchFamily="34" charset="-122"/>
+                <a:cs typeface="Be Vietnam Pro" pitchFamily="34" charset="-120"/>
+              </a:rPr>
+              <a:t> bàn</a:t>
+            </a:r>
+            <a:r>
+              <a:rPr lang="en-US" sz="2550" dirty="0" spc="-18" kern="0">
+                <a:solidFill>
+                  <a:srgbClr val="14161C"/>
+                </a:solidFill>
+                <a:latin typeface="Be Vietnam Pro" pitchFamily="34" charset="0"/>
+                <a:ea typeface="Be Vietnam Pro" pitchFamily="34" charset="-122"/>
+                <a:cs typeface="Be Vietnam Pro" pitchFamily="34" charset="-120"/>
+              </a:rPr>
+              <a:t> về</a:t>
+            </a:r>
+            <a:r>
+              <a:rPr lang="en-US" sz="2550" dirty="0" spc="-4" kern="0">
+                <a:solidFill>
+                  <a:srgbClr val="14161C"/>
+                </a:solidFill>
+                <a:latin typeface="Be Vietnam Pro" pitchFamily="34" charset="0"/>
+                <a:ea typeface="Be Vietnam Pro" pitchFamily="34" charset="-122"/>
+                <a:cs typeface="Be Vietnam Pro" pitchFamily="34" charset="-120"/>
+              </a:rPr>
+              <a:t> việc</a:t>
+            </a:r>
+            <a:r>
+              <a:rPr lang="en-US" sz="2550" dirty="0" spc="2" kern="0">
+                <a:solidFill>
+                  <a:srgbClr val="14161C"/>
+                </a:solidFill>
+                <a:latin typeface="Be Vietnam Pro" pitchFamily="34" charset="0"/>
+                <a:ea typeface="Be Vietnam Pro" pitchFamily="34" charset="-122"/>
+                <a:cs typeface="Be Vietnam Pro" pitchFamily="34" charset="-120"/>
+              </a:rPr>
+              <a:t> gì</a:t>
             </a:r>
             <a:endParaRPr lang="en-US" sz="2550" dirty="0"/>
           </a:p>
@@ -3977,29 +3955,18 @@
                 <a:ea typeface="Be Vietnam Pro" pitchFamily="34" charset="-122"/>
                 <a:cs typeface="Be Vietnam Pro" pitchFamily="34" charset="-120"/>
               </a:rPr>
-              <a:t> chỗ</a:t>
-            </a:r>
-            <a:r>
-              <a:rPr lang="en-US" sz="2550" dirty="0" spc="1" kern="0">
-                <a:solidFill>
-                  <a:srgbClr val="14161C"/>
-                </a:solidFill>
-                <a:latin typeface="Be Vietnam Pro" pitchFamily="34" charset="0"/>
-                <a:ea typeface="Be Vietnam Pro" pitchFamily="34" charset="-122"/>
-                <a:cs typeface="Be Vietnam Pro" pitchFamily="34" charset="-120"/>
-              </a:rPr>
-              <a:t> nguồn</a:t>
-            </a:r>
-            <a:r>
-              <a:rPr lang="en-US" sz="2550" dirty="0" spc="0" kern="0">
-                <a:solidFill>
-                  <a:srgbClr val="14161C"/>
-                </a:solidFill>
-                <a:latin typeface="Be Vietnam Pro" pitchFamily="34" charset="0"/>
-                <a:ea typeface="Be Vietnam Pro" pitchFamily="34" charset="-122"/>
-                <a:cs typeface="Be Vietnam Pro" pitchFamily="34" charset="-120"/>
-              </a:rPr>
-              <a:t> không</a:t>
+              <a:t> giới hạn</a:t>
+            </a:r>
+            <a:r>
+              <a:rPr lang="en-US" sz="2550" dirty="0" spc="-2" kern="0">
+                <a:solidFill>
+                  <a:srgbClr val="14161C"/>
+                </a:solidFill>
+                <a:latin typeface="Be Vietnam Pro" pitchFamily="34" charset="0"/>
+                <a:ea typeface="Be Vietnam Pro" pitchFamily="34" charset="-122"/>
+                <a:cs typeface="Be Vietnam Pro" pitchFamily="34" charset="-120"/>
+              </a:rPr>
+              <a:t> của</a:t>
             </a:r>
             <a:r>
               <a:rPr lang="en-US" sz="2550" dirty="0" spc="-1" kern="0">
@@ -4010,18 +3977,18 @@
                 <a:ea typeface="Be Vietnam Pro" pitchFamily="34" charset="-122"/>
                 <a:cs typeface="Be Vietnam Pro" pitchFamily="34" charset="-120"/>
               </a:rPr>
-              <a:t> nói</a:t>
-            </a:r>
-            <a:r>
-              <a:rPr lang="en-US" sz="2550" dirty="0" spc="2" kern="0">
-                <a:solidFill>
-                  <a:srgbClr val="14161C"/>
-                </a:solidFill>
-                <a:latin typeface="Be Vietnam Pro" pitchFamily="34" charset="0"/>
-                <a:ea typeface="Be Vietnam Pro" pitchFamily="34" charset="-122"/>
-                <a:cs typeface="Be Vietnam Pro" pitchFamily="34" charset="-120"/>
-              </a:rPr>
-              <a:t> gì</a:t>
+              <a:t> danh</a:t>
+            </a:r>
+            <a:r>
+              <a:rPr lang="en-US" sz="2550" dirty="0" spc="-5" kern="0">
+                <a:solidFill>
+                  <a:srgbClr val="14161C"/>
+                </a:solidFill>
+                <a:latin typeface="Be Vietnam Pro" pitchFamily="34" charset="0"/>
+                <a:ea typeface="Be Vietnam Pro" pitchFamily="34" charset="-122"/>
+                <a:cs typeface="Be Vietnam Pro" pitchFamily="34" charset="-120"/>
+              </a:rPr>
+              <a:t> sách</a:t>
             </a:r>
             <a:endParaRPr lang="en-US" sz="2550" dirty="0"/>
           </a:p>
@@ -6618,7 +6585,7 @@
               <a:buNone/>
             </a:pPr>
             <a:r>
-              <a:rPr lang="en-US" sz="2100" dirty="0" spc="-23" kern="0">
+              <a:rPr lang="en-US" sz="2100" dirty="0" spc="-9" kern="0">
                 <a:solidFill>
                   <a:srgbClr val="55544F"/>
                 </a:solidFill>
@@ -6626,10 +6593,10 @@
                 <a:ea typeface="Be Vietnam Pro" pitchFamily="34" charset="-122"/>
                 <a:cs typeface="Be Vietnam Pro" pitchFamily="34" charset="-120"/>
               </a:rPr>
-              <a:t>Andrew</a:t>
-            </a:r>
-            <a:r>
-              <a:rPr lang="en-US" sz="2100" dirty="0" spc="-8" kern="0">
+              <a:t>Hunt</a:t>
+            </a:r>
+            <a:r>
+              <a:rPr lang="en-US" sz="2100" dirty="0" spc="-18" kern="0">
                 <a:solidFill>
                   <a:srgbClr val="55544F"/>
                 </a:solidFill>
@@ -6637,10 +6604,10 @@
                 <a:ea typeface="Be Vietnam Pro" pitchFamily="34" charset="-122"/>
                 <a:cs typeface="Be Vietnam Pro" pitchFamily="34" charset="-120"/>
               </a:rPr>
-              <a:t> Hunt</a:t>
-            </a:r>
-            <a:r>
-              <a:rPr lang="en-US" sz="2100" dirty="0" spc="-18" kern="0">
+              <a:t> và</a:t>
+            </a:r>
+            <a:r>
+              <a:rPr lang="en-US" sz="2100" dirty="0" spc="0" kern="0">
                 <a:solidFill>
                   <a:srgbClr val="55544F"/>
                 </a:solidFill>
@@ -6648,10 +6615,10 @@
                 <a:ea typeface="Be Vietnam Pro" pitchFamily="34" charset="-122"/>
                 <a:cs typeface="Be Vietnam Pro" pitchFamily="34" charset="-120"/>
               </a:rPr>
-              <a:t> và</a:t>
-            </a:r>
-            <a:r>
-              <a:rPr lang="en-US" sz="2100" dirty="0" spc="-8" kern="0">
+              <a:t> Thomas</a:t>
+            </a:r>
+            <a:r>
+              <a:rPr lang="en-US" sz="2100" dirty="0" spc="-4" kern="0">
                 <a:solidFill>
                   <a:srgbClr val="55544F"/>
                 </a:solidFill>
@@ -6659,7 +6626,18 @@
                 <a:ea typeface="Be Vietnam Pro" pitchFamily="34" charset="-122"/>
                 <a:cs typeface="Be Vietnam Pro" pitchFamily="34" charset="-120"/>
               </a:rPr>
-              <a:t> David</a:t>
+              <a:t> ·</a:t>
+            </a:r>
+            <a:r>
+              <a:rPr lang="en-US" sz="2100" dirty="0" spc="-2" kern="0">
+                <a:solidFill>
+                  <a:srgbClr val="55544F"/>
+                </a:solidFill>
+                <a:latin typeface="Be Vietnam Pro" pitchFamily="34" charset="0"/>
+                <a:ea typeface="Be Vietnam Pro" pitchFamily="34" charset="-122"/>
+                <a:cs typeface="Be Vietnam Pro" pitchFamily="34" charset="-120"/>
+              </a:rPr>
+              <a:t> thói quen làm</a:t>
             </a:r>
             <a:r>
               <a:rPr lang="en-US" sz="2100" dirty="0" spc="0" kern="0">
@@ -6670,7 +6648,7 @@
                 <a:ea typeface="Be Vietnam Pro" pitchFamily="34" charset="-122"/>
                 <a:cs typeface="Be Vietnam Pro" pitchFamily="34" charset="-120"/>
               </a:rPr>
-              <a:t> Thomas</a:t>
+              <a:t> nghề</a:t>
             </a:r>
             <a:endParaRPr lang="en-US" sz="2100" dirty="0"/>
           </a:p>
@@ -6795,7 +6773,7 @@
               <a:buNone/>
             </a:pPr>
             <a:r>
-              <a:rPr lang="en-US" sz="2100" dirty="0" spc="-29" kern="0">
+              <a:rPr lang="en-US" sz="2100" dirty="0" spc="0" kern="0">
                 <a:solidFill>
                   <a:srgbClr val="55544F"/>
                 </a:solidFill>
@@ -6803,7 +6781,73 @@
                 <a:ea typeface="Be Vietnam Pro" pitchFamily="34" charset="-122"/>
                 <a:cs typeface="Be Vietnam Pro" pitchFamily="34" charset="-120"/>
               </a:rPr>
-              <a:t>Steve</a:t>
+              <a:t>McConnell</a:t>
+            </a:r>
+            <a:r>
+              <a:rPr lang="en-US" sz="2100" dirty="0" spc="-2" kern="0">
+                <a:solidFill>
+                  <a:srgbClr val="55544F"/>
+                </a:solidFill>
+                <a:latin typeface="Be Vietnam Pro" pitchFamily="34" charset="0"/>
+                <a:ea typeface="Be Vietnam Pro" pitchFamily="34" charset="-122"/>
+                <a:cs typeface="Be Vietnam Pro" pitchFamily="34" charset="-120"/>
+              </a:rPr>
+              <a:t> ·</a:t>
+            </a:r>
+            <a:r>
+              <a:rPr lang="en-US" sz="2100" dirty="0" spc="-9" kern="0">
+                <a:solidFill>
+                  <a:srgbClr val="55544F"/>
+                </a:solidFill>
+                <a:latin typeface="Be Vietnam Pro" pitchFamily="34" charset="0"/>
+                <a:ea typeface="Be Vietnam Pro" pitchFamily="34" charset="-122"/>
+                <a:cs typeface="Be Vietnam Pro" pitchFamily="34" charset="-120"/>
+              </a:rPr>
+              <a:t> sổ</a:t>
+            </a:r>
+            <a:r>
+              <a:rPr lang="en-US" sz="2100" dirty="0" spc="-20" kern="0">
+                <a:solidFill>
+                  <a:srgbClr val="55544F"/>
+                </a:solidFill>
+                <a:latin typeface="Be Vietnam Pro" pitchFamily="34" charset="0"/>
+                <a:ea typeface="Be Vietnam Pro" pitchFamily="34" charset="-122"/>
+                <a:cs typeface="Be Vietnam Pro" pitchFamily="34" charset="-120"/>
+              </a:rPr>
+              <a:t> tay</a:t>
+            </a:r>
+            <a:r>
+              <a:rPr lang="en-US" sz="2100" dirty="0" spc="-27" kern="0">
+                <a:solidFill>
+                  <a:srgbClr val="55544F"/>
+                </a:solidFill>
+                <a:latin typeface="Be Vietnam Pro" pitchFamily="34" charset="0"/>
+                <a:ea typeface="Be Vietnam Pro" pitchFamily="34" charset="-122"/>
+                <a:cs typeface="Be Vietnam Pro" pitchFamily="34" charset="-120"/>
+              </a:rPr>
+              <a:t> xây</a:t>
+            </a:r>
+            <a:r>
+              <a:rPr lang="en-US" sz="2100" dirty="0" spc="17" kern="0">
+                <a:solidFill>
+                  <a:srgbClr val="55544F"/>
+                </a:solidFill>
+                <a:latin typeface="Be Vietnam Pro" pitchFamily="34" charset="0"/>
+                <a:ea typeface="Be Vietnam Pro" pitchFamily="34" charset="-122"/>
+                <a:cs typeface="Be Vietnam Pro" pitchFamily="34" charset="-120"/>
+              </a:rPr>
+              <a:t> dựng</a:t>
+            </a:r>
+            <a:r>
+              <a:rPr lang="en-US" sz="2100" dirty="0" spc="-3" kern="0">
+                <a:solidFill>
+                  <a:srgbClr val="55544F"/>
+                </a:solidFill>
+                <a:latin typeface="Be Vietnam Pro" pitchFamily="34" charset="0"/>
+                <a:ea typeface="Be Vietnam Pro" pitchFamily="34" charset="-122"/>
+                <a:cs typeface="Be Vietnam Pro" pitchFamily="34" charset="-120"/>
+              </a:rPr>
+              <a:t> phần</a:t>
             </a:r>
             <a:r>
               <a:rPr lang="en-US" sz="2100" dirty="0" spc="0" kern="0">
@@ -6814,7 +6858,7 @@
                 <a:ea typeface="Be Vietnam Pro" pitchFamily="34" charset="-122"/>
                 <a:cs typeface="Be Vietnam Pro" pitchFamily="34" charset="-120"/>
               </a:rPr>
-              <a:t> McConnell</a:t>
+              <a:t> mềm</a:t>
             </a:r>
             <a:endParaRPr lang="en-US" sz="2100" dirty="0"/>
           </a:p>
@@ -7004,7 +7048,7 @@
               <a:buNone/>
             </a:pPr>
             <a:r>
-              <a:rPr lang="en-US" sz="2100" dirty="0" spc="-21" kern="0">
+              <a:rPr lang="en-US" sz="2100" dirty="0" spc="1" kern="0">
                 <a:solidFill>
                   <a:srgbClr val="55544F"/>
                 </a:solidFill>
@@ -7012,10 +7056,10 @@
                 <a:ea typeface="Be Vietnam Pro" pitchFamily="34" charset="-122"/>
                 <a:cs typeface="Be Vietnam Pro" pitchFamily="34" charset="-120"/>
               </a:rPr>
-              <a:t>Robert</a:t>
-            </a:r>
-            <a:r>
-              <a:rPr lang="en-US" sz="2100" dirty="0" spc="-1" kern="0">
+              <a:t>Martin</a:t>
+            </a:r>
+            <a:r>
+              <a:rPr lang="en-US" sz="2100" dirty="0" spc="-3" kern="0">
                 <a:solidFill>
                   <a:srgbClr val="55544F"/>
                 </a:solidFill>
@@ -7023,10 +7067,10 @@
                 <a:ea typeface="Be Vietnam Pro" pitchFamily="34" charset="-122"/>
                 <a:cs typeface="Be Vietnam Pro" pitchFamily="34" charset="-120"/>
               </a:rPr>
-              <a:t> C.</a:t>
-            </a:r>
-            <a:r>
-              <a:rPr lang="en-US" sz="2100" dirty="0" spc="0" kern="0">
+              <a:t> · mã</a:t>
+            </a:r>
+            <a:r>
+              <a:rPr lang="en-US" sz="2100" dirty="0" spc="-2" kern="0">
                 <a:solidFill>
                   <a:srgbClr val="55544F"/>
                 </a:solidFill>
@@ -7034,7 +7078,40 @@
                 <a:ea typeface="Be Vietnam Pro" pitchFamily="34" charset="-122"/>
                 <a:cs typeface="Be Vietnam Pro" pitchFamily="34" charset="-120"/>
               </a:rPr>
-              <a:t> Martin</a:t>
+              <a:t> dễ</a:t>
+            </a:r>
+            <a:r>
+              <a:rPr lang="en-US" sz="2100" dirty="0" spc="5" kern="0">
+                <a:solidFill>
+                  <a:srgbClr val="55544F"/>
+                </a:solidFill>
+                <a:latin typeface="Be Vietnam Pro" pitchFamily="34" charset="0"/>
+                <a:ea typeface="Be Vietnam Pro" pitchFamily="34" charset="-122"/>
+                <a:cs typeface="Be Vietnam Pro" pitchFamily="34" charset="-120"/>
+              </a:rPr>
+              <a:t> đọc,</a:t>
+            </a:r>
+            <a:r>
+              <a:rPr lang="en-US" sz="2100" dirty="0" spc="-3" kern="0">
+                <a:solidFill>
+                  <a:srgbClr val="55544F"/>
+                </a:solidFill>
+                <a:latin typeface="Be Vietnam Pro" pitchFamily="34" charset="0"/>
+                <a:ea typeface="Be Vietnam Pro" pitchFamily="34" charset="-122"/>
+                <a:cs typeface="Be Vietnam Pro" pitchFamily="34" charset="-120"/>
+              </a:rPr>
+              <a:t> dễ</a:t>
+            </a:r>
+            <a:r>
+              <a:rPr lang="en-US" sz="2100" dirty="0" spc="9" kern="0">
+                <a:solidFill>
+                  <a:srgbClr val="55544F"/>
+                </a:solidFill>
+                <a:latin typeface="Be Vietnam Pro" pitchFamily="34" charset="0"/>
+                <a:ea typeface="Be Vietnam Pro" pitchFamily="34" charset="-122"/>
+                <a:cs typeface="Be Vietnam Pro" pitchFamily="34" charset="-120"/>
+              </a:rPr>
+              <a:t> sửa</a:t>
             </a:r>
             <a:endParaRPr lang="en-US" sz="2100" dirty="0"/>
           </a:p>
@@ -7148,7 +7225,7 @@
               <a:buNone/>
             </a:pPr>
             <a:r>
-              <a:rPr lang="en-US" sz="2100" dirty="0" spc="1" kern="0">
+              <a:rPr lang="en-US" sz="2100" dirty="0" spc="-25" kern="0">
                 <a:solidFill>
                   <a:srgbClr val="55544F"/>
                 </a:solidFill>
@@ -7156,10 +7233,10 @@
                 <a:ea typeface="Be Vietnam Pro" pitchFamily="34" charset="-122"/>
                 <a:cs typeface="Be Vietnam Pro" pitchFamily="34" charset="-120"/>
               </a:rPr>
-              <a:t>Martin</a:t>
-            </a:r>
-            <a:r>
-              <a:rPr lang="en-US" sz="2100" dirty="0" spc="-22" kern="0">
+              <a:t>Fowler</a:t>
+            </a:r>
+            <a:r>
+              <a:rPr lang="en-US" sz="2100" dirty="0" spc="-4" kern="0">
                 <a:solidFill>
                   <a:srgbClr val="55544F"/>
                 </a:solidFill>
@@ -7167,7 +7244,51 @@
                 <a:ea typeface="Be Vietnam Pro" pitchFamily="34" charset="-122"/>
                 <a:cs typeface="Be Vietnam Pro" pitchFamily="34" charset="-120"/>
               </a:rPr>
-              <a:t> Fowler</a:t>
+              <a:t> ·</a:t>
+            </a:r>
+            <a:r>
+              <a:rPr lang="en-US" sz="2100" dirty="0" spc="8" kern="0">
+                <a:solidFill>
+                  <a:srgbClr val="55544F"/>
+                </a:solidFill>
+                <a:latin typeface="Be Vietnam Pro" pitchFamily="34" charset="0"/>
+                <a:ea typeface="Be Vietnam Pro" pitchFamily="34" charset="-122"/>
+                <a:cs typeface="Be Vietnam Pro" pitchFamily="34" charset="-120"/>
+              </a:rPr>
+              <a:t> sửa</a:t>
+            </a:r>
+            <a:r>
+              <a:rPr lang="en-US" sz="2100" dirty="0" spc="-2" kern="0">
+                <a:solidFill>
+                  <a:srgbClr val="55544F"/>
+                </a:solidFill>
+                <a:latin typeface="Be Vietnam Pro" pitchFamily="34" charset="0"/>
+                <a:ea typeface="Be Vietnam Pro" pitchFamily="34" charset="-122"/>
+                <a:cs typeface="Be Vietnam Pro" pitchFamily="34" charset="-120"/>
+              </a:rPr>
+              <a:t> mã,</a:t>
+            </a:r>
+            <a:r>
+              <a:rPr lang="en-US" sz="2100" dirty="0" spc="-1" kern="0">
+                <a:solidFill>
+                  <a:srgbClr val="55544F"/>
+                </a:solidFill>
+                <a:latin typeface="Be Vietnam Pro" pitchFamily="34" charset="0"/>
+                <a:ea typeface="Be Vietnam Pro" pitchFamily="34" charset="-122"/>
+                <a:cs typeface="Be Vietnam Pro" pitchFamily="34" charset="-120"/>
+              </a:rPr>
+              <a:t> hành vi không</a:t>
+            </a:r>
+            <a:r>
+              <a:rPr lang="en-US" sz="2100" dirty="0" spc="10" kern="0">
+                <a:solidFill>
+                  <a:srgbClr val="55544F"/>
+                </a:solidFill>
+                <a:latin typeface="Be Vietnam Pro" pitchFamily="34" charset="0"/>
+                <a:ea typeface="Be Vietnam Pro" pitchFamily="34" charset="-122"/>
+                <a:cs typeface="Be Vietnam Pro" pitchFamily="34" charset="-120"/>
+              </a:rPr>
+              <a:t> đổi</a:t>
             </a:r>
             <a:endParaRPr lang="en-US" sz="2100" dirty="0"/>
           </a:p>
@@ -8518,7 +8639,7 @@
               <a:buNone/>
             </a:pPr>
             <a:r>
-              <a:rPr lang="en-US" sz="2100" dirty="0" spc="1" kern="0">
+              <a:rPr lang="en-US" sz="2100" dirty="0" spc="-1" kern="0">
                 <a:solidFill>
                   <a:srgbClr val="C4C8D6"/>
                 </a:solidFill>
@@ -8526,7 +8647,62 @@
                 <a:ea typeface="Be Vietnam Pro" pitchFamily="34" charset="-122"/>
                 <a:cs typeface="Be Vietnam Pro" pitchFamily="34" charset="-120"/>
               </a:rPr>
-              <a:t>Martin</a:t>
+              <a:t>Kleppmann</a:t>
+            </a:r>
+            <a:r>
+              <a:rPr lang="en-US" sz="2100" dirty="0" spc="-5" kern="0">
+                <a:solidFill>
+                  <a:srgbClr val="C4C8D6"/>
+                </a:solidFill>
+                <a:latin typeface="Be Vietnam Pro" pitchFamily="34" charset="0"/>
+                <a:ea typeface="Be Vietnam Pro" pitchFamily="34" charset="-122"/>
+                <a:cs typeface="Be Vietnam Pro" pitchFamily="34" charset="-120"/>
+              </a:rPr>
+              <a:t> ·</a:t>
+            </a:r>
+            <a:r>
+              <a:rPr lang="en-US" sz="2100" dirty="0" spc="14" kern="0">
+                <a:solidFill>
+                  <a:srgbClr val="C4C8D6"/>
+                </a:solidFill>
+                <a:latin typeface="Be Vietnam Pro" pitchFamily="34" charset="0"/>
+                <a:ea typeface="Be Vietnam Pro" pitchFamily="34" charset="-122"/>
+                <a:cs typeface="Be Vietnam Pro" pitchFamily="34" charset="-120"/>
+              </a:rPr>
+              <a:t> lưu</a:t>
+            </a:r>
+            <a:r>
+              <a:rPr lang="en-US" sz="2100" dirty="0" spc="-1" kern="0">
+                <a:solidFill>
+                  <a:srgbClr val="C4C8D6"/>
+                </a:solidFill>
+                <a:latin typeface="Be Vietnam Pro" pitchFamily="34" charset="0"/>
+                <a:ea typeface="Be Vietnam Pro" pitchFamily="34" charset="-122"/>
+                <a:cs typeface="Be Vietnam Pro" pitchFamily="34" charset="-120"/>
+              </a:rPr>
+              <a:t> trữ</a:t>
+            </a:r>
+            <a:r>
+              <a:rPr lang="en-US" sz="2100" dirty="0" spc="-18" kern="0">
+                <a:solidFill>
+                  <a:srgbClr val="C4C8D6"/>
+                </a:solidFill>
+                <a:latin typeface="Be Vietnam Pro" pitchFamily="34" charset="0"/>
+                <a:ea typeface="Be Vietnam Pro" pitchFamily="34" charset="-122"/>
+                <a:cs typeface="Be Vietnam Pro" pitchFamily="34" charset="-120"/>
+              </a:rPr>
+              <a:t> và</a:t>
+            </a:r>
+            <a:r>
+              <a:rPr lang="en-US" sz="2100" dirty="0" spc="-1" kern="0">
+                <a:solidFill>
+                  <a:srgbClr val="C4C8D6"/>
+                </a:solidFill>
+                <a:latin typeface="Be Vietnam Pro" pitchFamily="34" charset="0"/>
+                <a:ea typeface="Be Vietnam Pro" pitchFamily="34" charset="-122"/>
+                <a:cs typeface="Be Vietnam Pro" pitchFamily="34" charset="-120"/>
+              </a:rPr>
+              <a:t> xử</a:t>
             </a:r>
             <a:r>
               <a:rPr lang="en-US" sz="2100" dirty="0" spc="-2" kern="0">
@@ -8537,7 +8713,18 @@
                 <a:ea typeface="Be Vietnam Pro" pitchFamily="34" charset="-122"/>
                 <a:cs typeface="Be Vietnam Pro" pitchFamily="34" charset="-120"/>
               </a:rPr>
-              <a:t> Kleppmann</a:t>
+              <a:t> lý dữ</a:t>
+            </a:r>
+            <a:r>
+              <a:rPr lang="en-US" sz="2100" dirty="0" spc="0" kern="0">
+                <a:solidFill>
+                  <a:srgbClr val="C4C8D6"/>
+                </a:solidFill>
+                <a:latin typeface="Be Vietnam Pro" pitchFamily="34" charset="0"/>
+                <a:ea typeface="Be Vietnam Pro" pitchFamily="34" charset="-122"/>
+                <a:cs typeface="Be Vietnam Pro" pitchFamily="34" charset="-120"/>
+              </a:rPr>
+              <a:t> liệu</a:t>
             </a:r>
             <a:endParaRPr lang="en-US" sz="2100" dirty="0"/>
           </a:p>
@@ -8673,7 +8860,7 @@
               <a:buNone/>
             </a:pPr>
             <a:r>
-              <a:rPr lang="en-US" sz="2100" dirty="0" spc="-2" kern="0">
+              <a:rPr lang="en-US" sz="2100" dirty="0" spc="-19" kern="0">
                 <a:solidFill>
                   <a:srgbClr val="C4C8D6"/>
                 </a:solidFill>
@@ -8681,7 +8868,40 @@
                 <a:ea typeface="Be Vietnam Pro" pitchFamily="34" charset="-122"/>
                 <a:cs typeface="Be Vietnam Pro" pitchFamily="34" charset="-120"/>
               </a:rPr>
-              <a:t>Sách</a:t>
+              <a:t>Alex</a:t>
+            </a:r>
+            <a:r>
+              <a:rPr lang="en-US" sz="2100" dirty="0" spc="-22" kern="0">
+                <a:solidFill>
+                  <a:srgbClr val="C4C8D6"/>
+                </a:solidFill>
+                <a:latin typeface="Be Vietnam Pro" pitchFamily="34" charset="0"/>
+                <a:ea typeface="Be Vietnam Pro" pitchFamily="34" charset="-122"/>
+                <a:cs typeface="Be Vietnam Pro" pitchFamily="34" charset="-120"/>
+              </a:rPr>
+              <a:t> Xu</a:t>
+            </a:r>
+            <a:r>
+              <a:rPr lang="en-US" sz="2100" dirty="0" spc="-3" kern="0">
+                <a:solidFill>
+                  <a:srgbClr val="C4C8D6"/>
+                </a:solidFill>
+                <a:latin typeface="Be Vietnam Pro" pitchFamily="34" charset="0"/>
+                <a:ea typeface="Be Vietnam Pro" pitchFamily="34" charset="-122"/>
+                <a:cs typeface="Be Vietnam Pro" pitchFamily="34" charset="-120"/>
+              </a:rPr>
+              <a:t> ·</a:t>
+            </a:r>
+            <a:r>
+              <a:rPr lang="en-US" sz="2100" dirty="0" spc="-5" kern="0">
+                <a:solidFill>
+                  <a:srgbClr val="C4C8D6"/>
+                </a:solidFill>
+                <a:latin typeface="Be Vietnam Pro" pitchFamily="34" charset="0"/>
+                <a:ea typeface="Be Vietnam Pro" pitchFamily="34" charset="-122"/>
+                <a:cs typeface="Be Vietnam Pro" pitchFamily="34" charset="-120"/>
+              </a:rPr>
+              <a:t> sách</a:t>
             </a:r>
             <a:r>
               <a:rPr lang="en-US" sz="2100" dirty="0" spc="-1" kern="0">
@@ -8726,17 +8946,6 @@
                 <a:cs typeface="Be Vietnam Pro" pitchFamily="34" charset="-120"/>
               </a:rPr>
               <a:t> viết</a:t>
-            </a:r>
-            <a:r>
-              <a:rPr lang="en-US" sz="2100" dirty="0" spc="-5" kern="0">
-                <a:solidFill>
-                  <a:srgbClr val="C4C8D6"/>
-                </a:solidFill>
-                <a:latin typeface="Be Vietnam Pro" pitchFamily="34" charset="0"/>
-                <a:ea typeface="Be Vietnam Pro" pitchFamily="34" charset="-122"/>
-                <a:cs typeface="Be Vietnam Pro" pitchFamily="34" charset="-120"/>
-              </a:rPr>
-              <a:t> bài</a:t>
             </a:r>
             <a:r>
               <a:rPr lang="en-US" sz="2100" dirty="0" spc="-1" kern="0">
@@ -8970,7 +9179,7 @@
               <a:buNone/>
             </a:pPr>
             <a:r>
-              <a:rPr lang="en-US" sz="2100" dirty="0" spc="0" kern="0">
+              <a:rPr lang="en-US" sz="2100" dirty="0" spc="-2" kern="0">
                 <a:solidFill>
                   <a:srgbClr val="C4C8D6"/>
                 </a:solidFill>
@@ -8978,7 +9187,29 @@
                 <a:ea typeface="Be Vietnam Pro" pitchFamily="34" charset="-122"/>
                 <a:cs typeface="Be Vietnam Pro" pitchFamily="34" charset="-120"/>
               </a:rPr>
-              <a:t>Nguồn ghi:</a:t>
+              <a:t>Gamma</a:t>
+            </a:r>
+            <a:r>
+              <a:rPr lang="en-US" sz="2100" dirty="0" spc="-17" kern="0">
+                <a:solidFill>
+                  <a:srgbClr val="C4C8D6"/>
+                </a:solidFill>
+                <a:latin typeface="Be Vietnam Pro" pitchFamily="34" charset="0"/>
+                <a:ea typeface="Be Vietnam Pro" pitchFamily="34" charset="-122"/>
+                <a:cs typeface="Be Vietnam Pro" pitchFamily="34" charset="-120"/>
+              </a:rPr>
+              <a:t> và</a:t>
+            </a:r>
+            <a:r>
+              <a:rPr lang="en-US" sz="2100" dirty="0" spc="-8" kern="0">
+                <a:solidFill>
+                  <a:srgbClr val="C4C8D6"/>
+                </a:solidFill>
+                <a:latin typeface="Be Vietnam Pro" pitchFamily="34" charset="0"/>
+                <a:ea typeface="Be Vietnam Pro" pitchFamily="34" charset="-122"/>
+                <a:cs typeface="Be Vietnam Pro" pitchFamily="34" charset="-120"/>
+              </a:rPr>
+              <a:t> ba</a:t>
             </a:r>
             <a:r>
               <a:rPr lang="en-US" sz="2100" dirty="0" spc="8" kern="0">
@@ -8989,7 +9220,29 @@
                 <a:ea typeface="Be Vietnam Pro" pitchFamily="34" charset="-122"/>
                 <a:cs typeface="Be Vietnam Pro" pitchFamily="34" charset="-120"/>
               </a:rPr>
-              <a:t> "Eric</a:t>
+              <a:t> đồng</a:t>
+            </a:r>
+            <a:r>
+              <a:rPr lang="en-US" sz="2100" dirty="0" spc="-13" kern="0">
+                <a:solidFill>
+                  <a:srgbClr val="C4C8D6"/>
+                </a:solidFill>
+                <a:latin typeface="Be Vietnam Pro" pitchFamily="34" charset="0"/>
+                <a:ea typeface="Be Vietnam Pro" pitchFamily="34" charset="-122"/>
+                <a:cs typeface="Be Vietnam Pro" pitchFamily="34" charset="-120"/>
+              </a:rPr>
+              <a:t> tác</a:t>
+            </a:r>
+            <a:r>
+              <a:rPr lang="en-US" sz="2100" dirty="0" spc="-1" kern="0">
+                <a:solidFill>
+                  <a:srgbClr val="C4C8D6"/>
+                </a:solidFill>
+                <a:latin typeface="Be Vietnam Pro" pitchFamily="34" charset="0"/>
+                <a:ea typeface="Be Vietnam Pro" pitchFamily="34" charset="-122"/>
+                <a:cs typeface="Be Vietnam Pro" pitchFamily="34" charset="-120"/>
+              </a:rPr>
+              <a:t> giả</a:t>
             </a:r>
             <a:r>
               <a:rPr lang="en-US" sz="2100" dirty="0" spc="-3" kern="0">
@@ -9000,10 +9253,10 @@
                 <a:ea typeface="Be Vietnam Pro" pitchFamily="34" charset="-122"/>
                 <a:cs typeface="Be Vietnam Pro" pitchFamily="34" charset="-120"/>
               </a:rPr>
-              <a:t> Gamma</a:t>
-            </a:r>
-            <a:r>
-              <a:rPr lang="en-US" sz="2100" dirty="0" spc="-17" kern="0">
+              <a:t> ·</a:t>
+            </a:r>
+            <a:r>
+              <a:rPr lang="en-US" sz="2100" dirty="0" spc="-2" kern="0">
                 <a:solidFill>
                   <a:srgbClr val="C4C8D6"/>
                 </a:solidFill>
@@ -9011,10 +9264,10 @@
                 <a:ea typeface="Be Vietnam Pro" pitchFamily="34" charset="-122"/>
                 <a:cs typeface="Be Vietnam Pro" pitchFamily="34" charset="-120"/>
               </a:rPr>
-              <a:t> và</a:t>
-            </a:r>
-            <a:r>
-              <a:rPr lang="en-US" sz="2100" dirty="0" spc="15" kern="0">
+              <a:t> mẫu</a:t>
+            </a:r>
+            <a:r>
+              <a:rPr lang="en-US" sz="2100" dirty="0" spc="-3" kern="0">
                 <a:solidFill>
                   <a:srgbClr val="C4C8D6"/>
                 </a:solidFill>
@@ -9022,10 +9275,10 @@
                 <a:ea typeface="Be Vietnam Pro" pitchFamily="34" charset="-122"/>
                 <a:cs typeface="Be Vietnam Pro" pitchFamily="34" charset="-120"/>
               </a:rPr>
-              <a:t> những</a:t>
-            </a:r>
-            <a:r>
-              <a:rPr lang="en-US" sz="2100" dirty="0" spc="4" kern="0">
+              <a:t> thiết</a:t>
+            </a:r>
+            <a:r>
+              <a:rPr lang="en-US" sz="2100" dirty="0" spc="-31" kern="0">
                 <a:solidFill>
                   <a:srgbClr val="C4C8D6"/>
                 </a:solidFill>
@@ -9033,18 +9286,7 @@
                 <a:ea typeface="Be Vietnam Pro" pitchFamily="34" charset="-122"/>
                 <a:cs typeface="Be Vietnam Pro" pitchFamily="34" charset="-120"/>
               </a:rPr>
-              <a:t> người</a:t>
-            </a:r>
-            <a:r>
-              <a:rPr lang="en-US" sz="2100" dirty="0" spc="0" kern="0">
-                <a:solidFill>
-                  <a:srgbClr val="C4C8D6"/>
-                </a:solidFill>
-                <a:latin typeface="Be Vietnam Pro" pitchFamily="34" charset="0"/>
-                <a:ea typeface="Be Vietnam Pro" pitchFamily="34" charset="-122"/>
-                <a:cs typeface="Be Vietnam Pro" pitchFamily="34" charset="-120"/>
-              </a:rPr>
-              <a:t> khác"</a:t>
+              <a:t> kế</a:t>
             </a:r>
             <a:endParaRPr lang="en-US" sz="2100" dirty="0"/>
           </a:p>
@@ -9169,7 +9411,7 @@
               <a:buNone/>
             </a:pPr>
             <a:r>
-              <a:rPr lang="en-US" sz="2100" dirty="0" spc="12" kern="0">
+              <a:rPr lang="en-US" sz="2100" dirty="0" spc="-7" kern="0">
                 <a:solidFill>
                   <a:srgbClr val="C4C8D6"/>
                 </a:solidFill>
@@ -9177,10 +9419,10 @@
                 <a:ea typeface="Be Vietnam Pro" pitchFamily="34" charset="-122"/>
                 <a:cs typeface="Be Vietnam Pro" pitchFamily="34" charset="-120"/>
               </a:rPr>
-              <a:t>Eric</a:t>
-            </a:r>
-            <a:r>
-              <a:rPr lang="en-US" sz="2100" dirty="0" spc="-7" kern="0">
+              <a:t>Evans</a:t>
+            </a:r>
+            <a:r>
+              <a:rPr lang="en-US" sz="2100" dirty="0" spc="-4" kern="0">
                 <a:solidFill>
                   <a:srgbClr val="C4C8D6"/>
                 </a:solidFill>
@@ -9188,7 +9430,51 @@
                 <a:ea typeface="Be Vietnam Pro" pitchFamily="34" charset="-122"/>
                 <a:cs typeface="Be Vietnam Pro" pitchFamily="34" charset="-120"/>
               </a:rPr>
-              <a:t> Evans</a:t>
+              <a:t> · mô</a:t>
+            </a:r>
+            <a:r>
+              <a:rPr lang="en-US" sz="2100" dirty="0" spc="1" kern="0">
+                <a:solidFill>
+                  <a:srgbClr val="C4C8D6"/>
+                </a:solidFill>
+                <a:latin typeface="Be Vietnam Pro" pitchFamily="34" charset="0"/>
+                <a:ea typeface="Be Vietnam Pro" pitchFamily="34" charset="-122"/>
+                <a:cs typeface="Be Vietnam Pro" pitchFamily="34" charset="-120"/>
+              </a:rPr>
+              <a:t> hình</a:t>
+            </a:r>
+            <a:r>
+              <a:rPr lang="en-US" sz="2100" dirty="0" spc="-6" kern="0">
+                <a:solidFill>
+                  <a:srgbClr val="C4C8D6"/>
+                </a:solidFill>
+                <a:latin typeface="Be Vietnam Pro" pitchFamily="34" charset="0"/>
+                <a:ea typeface="Be Vietnam Pro" pitchFamily="34" charset="-122"/>
+                <a:cs typeface="Be Vietnam Pro" pitchFamily="34" charset="-120"/>
+              </a:rPr>
+              <a:t> hóa</a:t>
+            </a:r>
+            <a:r>
+              <a:rPr lang="en-US" sz="2100" dirty="0" spc="1" kern="0">
+                <a:solidFill>
+                  <a:srgbClr val="C4C8D6"/>
+                </a:solidFill>
+                <a:latin typeface="Be Vietnam Pro" pitchFamily="34" charset="0"/>
+                <a:ea typeface="Be Vietnam Pro" pitchFamily="34" charset="-122"/>
+                <a:cs typeface="Be Vietnam Pro" pitchFamily="34" charset="-120"/>
+              </a:rPr>
+              <a:t> miền</a:t>
+            </a:r>
+            <a:r>
+              <a:rPr lang="en-US" sz="2100" dirty="0" spc="0" kern="0">
+                <a:solidFill>
+                  <a:srgbClr val="C4C8D6"/>
+                </a:solidFill>
+                <a:latin typeface="Be Vietnam Pro" pitchFamily="34" charset="0"/>
+                <a:ea typeface="Be Vietnam Pro" pitchFamily="34" charset="-122"/>
+                <a:cs typeface="Be Vietnam Pro" pitchFamily="34" charset="-120"/>
+              </a:rPr>
+              <a:t> nghiệp vụ</a:t>
             </a:r>
             <a:endParaRPr lang="en-US" sz="2100" dirty="0"/>
           </a:p>
@@ -10093,6 +10379,28 @@
               <a:buNone/>
             </a:pPr>
             <a:r>
+              <a:rPr lang="en-US" sz="2700" dirty="0" spc="-1" kern="0">
+                <a:solidFill>
+                  <a:srgbClr val="14161C"/>
+                </a:solidFill>
+                <a:latin typeface="Be Vietnam Pro" pitchFamily="34" charset="0"/>
+                <a:ea typeface="Be Vietnam Pro" pitchFamily="34" charset="-122"/>
+                <a:cs typeface="Be Vietnam Pro" pitchFamily="34" charset="-120"/>
+              </a:rPr>
+              <a:t>Hai</a:t>
+            </a:r>
+            <a:r>
+              <a:rPr lang="en-US" sz="2700" dirty="0" spc="1" kern="0">
+                <a:solidFill>
+                  <a:srgbClr val="14161C"/>
+                </a:solidFill>
+                <a:latin typeface="Be Vietnam Pro" pitchFamily="34" charset="0"/>
+                <a:ea typeface="Be Vietnam Pro" pitchFamily="34" charset="-122"/>
+                <a:cs typeface="Be Vietnam Pro" pitchFamily="34" charset="-120"/>
+              </a:rPr>
+              <a:t> cuốn,</a:t>
+            </a:r>
+            <a:r>
               <a:rPr lang="en-US" sz="2700" dirty="0" spc="-2" kern="0">
                 <a:solidFill>
                   <a:srgbClr val="14161C"/>
@@ -10101,18 +10409,18 @@
                 <a:ea typeface="Be Vietnam Pro" pitchFamily="34" charset="-122"/>
                 <a:cs typeface="Be Vietnam Pro" pitchFamily="34" charset="-120"/>
               </a:rPr>
-              <a:t>Code</a:t>
-            </a:r>
-            <a:r>
-              <a:rPr lang="en-US" sz="2700" dirty="0" spc="-8" kern="0">
-                <a:solidFill>
-                  <a:srgbClr val="14161C"/>
-                </a:solidFill>
-                <a:latin typeface="Be Vietnam Pro" pitchFamily="34" charset="0"/>
-                <a:ea typeface="Be Vietnam Pro" pitchFamily="34" charset="-122"/>
-                <a:cs typeface="Be Vietnam Pro" pitchFamily="34" charset="-120"/>
-              </a:rPr>
-              <a:t> Complete</a:t>
+              <a:t> hai</a:t>
+            </a:r>
+            <a:r>
+              <a:rPr lang="en-US" sz="2700" dirty="0" spc="-3" kern="0">
+                <a:solidFill>
+                  <a:srgbClr val="14161C"/>
+                </a:solidFill>
+                <a:latin typeface="Be Vietnam Pro" pitchFamily="34" charset="0"/>
+                <a:ea typeface="Be Vietnam Pro" pitchFamily="34" charset="-122"/>
+                <a:cs typeface="Be Vietnam Pro" pitchFamily="34" charset="-120"/>
+              </a:rPr>
+              <a:t> việc:</a:t>
             </a:r>
             <a:r>
               <a:rPr lang="en-US" sz="2700" dirty="0" spc="-1" kern="0">
@@ -10123,40 +10431,40 @@
                 <a:ea typeface="Be Vietnam Pro" pitchFamily="34" charset="-122"/>
                 <a:cs typeface="Be Vietnam Pro" pitchFamily="34" charset="-120"/>
               </a:rPr>
-              <a:t> là</a:t>
-            </a:r>
-            <a:r>
-              <a:rPr lang="en-US" sz="2700" dirty="0" spc="0" kern="0">
-                <a:solidFill>
-                  <a:srgbClr val="14161C"/>
-                </a:solidFill>
-                <a:latin typeface="Be Vietnam Pro" pitchFamily="34" charset="0"/>
-                <a:ea typeface="Be Vietnam Pro" pitchFamily="34" charset="-122"/>
-                <a:cs typeface="Be Vietnam Pro" pitchFamily="34" charset="-120"/>
-              </a:rPr>
-              <a:t> cuốn</a:t>
-            </a:r>
-            <a:r>
-              <a:rPr lang="en-US" sz="2700" dirty="0" spc="-1" kern="0">
-                <a:solidFill>
-                  <a:srgbClr val="14161C"/>
-                </a:solidFill>
-                <a:latin typeface="Be Vietnam Pro" pitchFamily="34" charset="0"/>
-                <a:ea typeface="Be Vietnam Pro" pitchFamily="34" charset="-122"/>
-                <a:cs typeface="Be Vietnam Pro" pitchFamily="34" charset="-120"/>
-              </a:rPr>
-              <a:t> duy</a:t>
-            </a:r>
-            <a:r>
-              <a:rPr lang="en-US" sz="2700" dirty="0" spc="-11" kern="0">
-                <a:solidFill>
-                  <a:srgbClr val="14161C"/>
-                </a:solidFill>
-                <a:latin typeface="Be Vietnam Pro" pitchFamily="34" charset="0"/>
-                <a:ea typeface="Be Vietnam Pro" pitchFamily="34" charset="-122"/>
-                <a:cs typeface="Be Vietnam Pro" pitchFamily="34" charset="-120"/>
-              </a:rPr>
-              <a:t> nhất</a:t>
+              <a:t> giáo</a:t>
+            </a:r>
+            <a:r>
+              <a:rPr lang="en-US" sz="2700" dirty="0" spc="7" kern="0">
+                <a:solidFill>
+                  <a:srgbClr val="14161C"/>
+                </a:solidFill>
+                <a:latin typeface="Be Vietnam Pro" pitchFamily="34" charset="0"/>
+                <a:ea typeface="Be Vietnam Pro" pitchFamily="34" charset="-122"/>
+                <a:cs typeface="Be Vietnam Pro" pitchFamily="34" charset="-120"/>
+              </a:rPr>
+              <a:t> trình</a:t>
+            </a:r>
+            <a:r>
+              <a:rPr lang="en-US" sz="2700" dirty="0" spc="-18" kern="0">
+                <a:solidFill>
+                  <a:srgbClr val="14161C"/>
+                </a:solidFill>
+                <a:latin typeface="Be Vietnam Pro" pitchFamily="34" charset="0"/>
+                <a:ea typeface="Be Vietnam Pro" pitchFamily="34" charset="-122"/>
+                <a:cs typeface="Be Vietnam Pro" pitchFamily="34" charset="-120"/>
+              </a:rPr>
+              <a:t> và</a:t>
+            </a:r>
+            <a:r>
+              <a:rPr lang="en-US" sz="2700" dirty="0" spc="-17" kern="0">
+                <a:solidFill>
+                  <a:srgbClr val="14161C"/>
+                </a:solidFill>
+                <a:latin typeface="Be Vietnam Pro" pitchFamily="34" charset="0"/>
+                <a:ea typeface="Be Vietnam Pro" pitchFamily="34" charset="-122"/>
+                <a:cs typeface="Be Vietnam Pro" pitchFamily="34" charset="-120"/>
+              </a:rPr>
+              <a:t> luyện</a:t>
             </a:r>
             <a:r>
               <a:rPr lang="en-US" sz="2700" dirty="0" spc="-2" kern="0">
@@ -10167,51 +10475,18 @@
                 <a:ea typeface="Be Vietnam Pro" pitchFamily="34" charset="-122"/>
                 <a:cs typeface="Be Vietnam Pro" pitchFamily="34" charset="-120"/>
               </a:rPr>
-              <a:t> nguồn</a:t>
-            </a:r>
-            <a:r>
-              <a:rPr lang="en-US" sz="2700" dirty="0" spc="0" kern="0">
-                <a:solidFill>
-                  <a:srgbClr val="14161C"/>
-                </a:solidFill>
-                <a:latin typeface="Be Vietnam Pro" pitchFamily="34" charset="0"/>
-                <a:ea typeface="Be Vietnam Pro" pitchFamily="34" charset="-122"/>
-                <a:cs typeface="Be Vietnam Pro" pitchFamily="34" charset="-120"/>
-              </a:rPr>
-              <a:t> có</a:t>
-            </a:r>
-            <a:r>
-              <a:rPr lang="en-US" sz="2700" dirty="0" spc="-1" kern="0">
-                <a:solidFill>
-                  <a:srgbClr val="14161C"/>
-                </a:solidFill>
-                <a:latin typeface="Be Vietnam Pro" pitchFamily="34" charset="0"/>
-                <a:ea typeface="Be Vietnam Pro" pitchFamily="34" charset="-122"/>
-                <a:cs typeface="Be Vietnam Pro" pitchFamily="34" charset="-120"/>
-              </a:rPr>
-              <a:t> lời</a:t>
-            </a:r>
-            <a:r>
-              <a:rPr lang="en-US" sz="2700" dirty="0" spc="-3" kern="0">
-                <a:solidFill>
-                  <a:srgbClr val="14161C"/>
-                </a:solidFill>
-                <a:latin typeface="Be Vietnam Pro" pitchFamily="34" charset="0"/>
-                <a:ea typeface="Be Vietnam Pro" pitchFamily="34" charset="-122"/>
-                <a:cs typeface="Be Vietnam Pro" pitchFamily="34" charset="-120"/>
-              </a:rPr>
-              <a:t> mô</a:t>
-            </a:r>
-            <a:r>
-              <a:rPr lang="en-US" sz="2700" dirty="0" spc="-14" kern="0">
-                <a:solidFill>
-                  <a:srgbClr val="14161C"/>
-                </a:solidFill>
-                <a:latin typeface="Be Vietnam Pro" pitchFamily="34" charset="0"/>
-                <a:ea typeface="Be Vietnam Pro" pitchFamily="34" charset="-122"/>
-                <a:cs typeface="Be Vietnam Pro" pitchFamily="34" charset="-120"/>
-              </a:rPr>
-              <a:t> tả.</a:t>
+              <a:t> phỏng</a:t>
+            </a:r>
+            <a:r>
+              <a:rPr lang="en-US" sz="2700" dirty="0" spc="-12" kern="0">
+                <a:solidFill>
+                  <a:srgbClr val="14161C"/>
+                </a:solidFill>
+                <a:latin typeface="Be Vietnam Pro" pitchFamily="34" charset="0"/>
+                <a:ea typeface="Be Vietnam Pro" pitchFamily="34" charset="-122"/>
+                <a:cs typeface="Be Vietnam Pro" pitchFamily="34" charset="-120"/>
+              </a:rPr>
+              <a:t> vấn.</a:t>
             </a:r>
             <a:endParaRPr lang="en-US" sz="2700" dirty="0"/>
           </a:p>
@@ -10758,7 +11033,7 @@
               <a:buNone/>
             </a:pPr>
             <a:r>
-              <a:rPr lang="en-US" sz="1800" b="1" dirty="0" spc="4" kern="0">
+              <a:rPr lang="en-US" sz="1800" b="1" dirty="0" spc="1" kern="0">
                 <a:solidFill>
                   <a:srgbClr val="F3EEE3"/>
                 </a:solidFill>
@@ -10766,7 +11041,18 @@
                 <a:ea typeface="Be Vietnam Pro" pitchFamily="34" charset="-122"/>
                 <a:cs typeface="Be Vietnam Pro" pitchFamily="34" charset="-120"/>
               </a:rPr>
-              <a:t>CODE</a:t>
+              <a:t>NHÓM</a:t>
+            </a:r>
+            <a:r>
+              <a:rPr lang="en-US" sz="1800" b="1" dirty="0" spc="2" kern="0">
+                <a:solidFill>
+                  <a:srgbClr val="F3EEE3"/>
+                </a:solidFill>
+                <a:latin typeface="Be Vietnam Pro" pitchFamily="34" charset="0"/>
+                <a:ea typeface="Be Vietnam Pro" pitchFamily="34" charset="-122"/>
+                <a:cs typeface="Be Vietnam Pro" pitchFamily="34" charset="-120"/>
+              </a:rPr>
+              <a:t> 5</a:t>
             </a:r>
             <a:r>
               <a:rPr lang="en-US" sz="1800" b="1" dirty="0" spc="1" kern="0">
@@ -10777,10 +11063,10 @@
                 <a:ea typeface="Be Vietnam Pro" pitchFamily="34" charset="-122"/>
                 <a:cs typeface="Be Vietnam Pro" pitchFamily="34" charset="-120"/>
               </a:rPr>
-              <a:t> COMPLETE</a:t>
-            </a:r>
-            <a:r>
-              <a:rPr lang="en-US" sz="1800" b="1" dirty="0" spc="-1" kern="0">
+              <a:t> ·</a:t>
+            </a:r>
+            <a:r>
+              <a:rPr lang="en-US" sz="1800" b="1" dirty="0" spc="0" kern="0">
                 <a:solidFill>
                   <a:srgbClr val="F3EEE3"/>
                 </a:solidFill>
@@ -10788,10 +11074,10 @@
                 <a:ea typeface="Be Vietnam Pro" pitchFamily="34" charset="-122"/>
                 <a:cs typeface="Be Vietnam Pro" pitchFamily="34" charset="-120"/>
               </a:rPr>
-              <a:t> ·</a:t>
-            </a:r>
-            <a:r>
-              <a:rPr lang="en-US" sz="1800" b="1" dirty="0" spc="-22" kern="0">
+              <a:t> HAI</a:t>
+            </a:r>
+            <a:r>
+              <a:rPr lang="en-US" sz="1800" b="1" dirty="0" spc="1" kern="0">
                 <a:solidFill>
                   <a:srgbClr val="F3EEE3"/>
                 </a:solidFill>
@@ -10799,10 +11085,10 @@
                 <a:ea typeface="Be Vietnam Pro" pitchFamily="34" charset="-122"/>
                 <a:cs typeface="Be Vietnam Pro" pitchFamily="34" charset="-120"/>
               </a:rPr>
-              <a:t> LỜI</a:t>
-            </a:r>
-            <a:r>
-              <a:rPr lang="en-US" sz="1800" b="1" dirty="0" spc="1" kern="0">
+              <a:t> CUỐN,</a:t>
+            </a:r>
+            <a:r>
+              <a:rPr lang="en-US" sz="1800" b="1" dirty="0" spc="0" kern="0">
                 <a:solidFill>
                   <a:srgbClr val="F3EEE3"/>
                 </a:solidFill>
@@ -10810,10 +11096,10 @@
                 <a:ea typeface="Be Vietnam Pro" pitchFamily="34" charset="-122"/>
                 <a:cs typeface="Be Vietnam Pro" pitchFamily="34" charset="-120"/>
               </a:rPr>
-              <a:t> MÔ</a:t>
-            </a:r>
-            <a:r>
-              <a:rPr lang="en-US" sz="1800" b="1" dirty="0" spc="-60" kern="0">
+              <a:t> HAI</a:t>
+            </a:r>
+            <a:r>
+              <a:rPr lang="en-US" sz="1800" b="1" dirty="0" spc="-3" kern="0">
                 <a:solidFill>
                   <a:srgbClr val="F3EEE3"/>
                 </a:solidFill>
@@ -10821,29 +11107,7 @@
                 <a:ea typeface="Be Vietnam Pro" pitchFamily="34" charset="-122"/>
                 <a:cs typeface="Be Vietnam Pro" pitchFamily="34" charset="-120"/>
               </a:rPr>
-              <a:t> TẢ</a:t>
-            </a:r>
-            <a:r>
-              <a:rPr lang="en-US" sz="1800" b="1" dirty="0" spc="8" kern="0">
-                <a:solidFill>
-                  <a:srgbClr val="F3EEE3"/>
-                </a:solidFill>
-                <a:latin typeface="Be Vietnam Pro" pitchFamily="34" charset="0"/>
-                <a:ea typeface="Be Vietnam Pro" pitchFamily="34" charset="-122"/>
-                <a:cs typeface="Be Vietnam Pro" pitchFamily="34" charset="-120"/>
-              </a:rPr>
-              <a:t> DUY</a:t>
-            </a:r>
-            <a:r>
-              <a:rPr lang="en-US" sz="1800" b="1" dirty="0" spc="-37" kern="0">
-                <a:solidFill>
-                  <a:srgbClr val="F3EEE3"/>
-                </a:solidFill>
-                <a:latin typeface="Be Vietnam Pro" pitchFamily="34" charset="0"/>
-                <a:ea typeface="Be Vietnam Pro" pitchFamily="34" charset="-122"/>
-                <a:cs typeface="Be Vietnam Pro" pitchFamily="34" charset="-120"/>
-              </a:rPr>
-              <a:t> NHẤT</a:t>
+              <a:t> VIỆC</a:t>
             </a:r>
             <a:endParaRPr lang="en-US" sz="1800" dirty="0"/>
           </a:p>
@@ -10918,26 +11182,26 @@
               <a:buNone/>
             </a:pPr>
             <a:r>
-              <a:rPr lang="en-US" sz="2400" b="1" dirty="0" spc="-7" kern="0">
-                <a:solidFill>
-                  <a:srgbClr val="14161C"/>
-                </a:solidFill>
-                <a:latin typeface="Be Vietnam Pro" pitchFamily="34" charset="0"/>
-                <a:ea typeface="Be Vietnam Pro" pitchFamily="34" charset="-122"/>
-                <a:cs typeface="Be Vietnam Pro" pitchFamily="34" charset="-120"/>
-              </a:rPr>
-              <a:t>Code</a:t>
-            </a:r>
-            <a:r>
-              <a:rPr lang="en-US" sz="2400" b="1" dirty="0" spc="-9" kern="0">
-                <a:solidFill>
-                  <a:srgbClr val="14161C"/>
-                </a:solidFill>
-                <a:latin typeface="Be Vietnam Pro" pitchFamily="34" charset="0"/>
-                <a:ea typeface="Be Vietnam Pro" pitchFamily="34" charset="-122"/>
-                <a:cs typeface="Be Vietnam Pro" pitchFamily="34" charset="-120"/>
-              </a:rPr>
-              <a:t> Complete</a:t>
+              <a:rPr lang="en-US" sz="2400" b="1" dirty="0" spc="-4" kern="0">
+                <a:solidFill>
+                  <a:srgbClr val="14161C"/>
+                </a:solidFill>
+                <a:latin typeface="Be Vietnam Pro" pitchFamily="34" charset="0"/>
+                <a:ea typeface="Be Vietnam Pro" pitchFamily="34" charset="-122"/>
+                <a:cs typeface="Be Vietnam Pro" pitchFamily="34" charset="-120"/>
+              </a:rPr>
+              <a:t>Hai</a:t>
+            </a:r>
+            <a:r>
+              <a:rPr lang="en-US" sz="2400" b="1" dirty="0" spc="-1" kern="0">
+                <a:solidFill>
+                  <a:srgbClr val="14161C"/>
+                </a:solidFill>
+                <a:latin typeface="Be Vietnam Pro" pitchFamily="34" charset="0"/>
+                <a:ea typeface="Be Vietnam Pro" pitchFamily="34" charset="-122"/>
+                <a:cs typeface="Be Vietnam Pro" pitchFamily="34" charset="-120"/>
+              </a:rPr>
+              <a:t> cuốn,</a:t>
             </a:r>
             <a:r>
               <a:rPr lang="en-US" sz="2400" b="1" dirty="0" spc="-2" kern="0">
@@ -10948,29 +11212,18 @@
                 <a:ea typeface="Be Vietnam Pro" pitchFamily="34" charset="-122"/>
                 <a:cs typeface="Be Vietnam Pro" pitchFamily="34" charset="-120"/>
               </a:rPr>
-              <a:t> ·</a:t>
-            </a:r>
-            <a:r>
-              <a:rPr lang="en-US" sz="2400" b="1" dirty="0" spc="-25" kern="0">
-                <a:solidFill>
-                  <a:srgbClr val="14161C"/>
-                </a:solidFill>
-                <a:latin typeface="Be Vietnam Pro" pitchFamily="34" charset="0"/>
-                <a:ea typeface="Be Vietnam Pro" pitchFamily="34" charset="-122"/>
-                <a:cs typeface="Be Vietnam Pro" pitchFamily="34" charset="-120"/>
-              </a:rPr>
-              <a:t> Steve</a:t>
-            </a:r>
-            <a:r>
-              <a:rPr lang="en-US" sz="2400" b="1" dirty="0" spc="-5" kern="0">
-                <a:solidFill>
-                  <a:srgbClr val="14161C"/>
-                </a:solidFill>
-                <a:latin typeface="Be Vietnam Pro" pitchFamily="34" charset="0"/>
-                <a:ea typeface="Be Vietnam Pro" pitchFamily="34" charset="-122"/>
-                <a:cs typeface="Be Vietnam Pro" pitchFamily="34" charset="-120"/>
-              </a:rPr>
-              <a:t> McConnell</a:t>
+              <a:t> hai</a:t>
+            </a:r>
+            <a:r>
+              <a:rPr lang="en-US" sz="2400" b="1" dirty="0" spc="-4" kern="0">
+                <a:solidFill>
+                  <a:srgbClr val="14161C"/>
+                </a:solidFill>
+                <a:latin typeface="Be Vietnam Pro" pitchFamily="34" charset="0"/>
+                <a:ea typeface="Be Vietnam Pro" pitchFamily="34" charset="-122"/>
+                <a:cs typeface="Be Vietnam Pro" pitchFamily="34" charset="-120"/>
+              </a:rPr>
+              <a:t> việc</a:t>
             </a:r>
             <a:endParaRPr lang="en-US" sz="2400" dirty="0"/>
           </a:p>
@@ -11009,15 +11262,15 @@
               <a:buChar char="•"/>
             </a:pPr>
             <a:r>
-              <a:rPr lang="en-US" sz="2400" dirty="0" spc="6" kern="0">
-                <a:solidFill>
-                  <a:srgbClr val="14161C"/>
-                </a:solidFill>
-                <a:latin typeface="Be Vietnam Pro" pitchFamily="34" charset="0"/>
-                <a:ea typeface="Be Vietnam Pro" pitchFamily="34" charset="-122"/>
-                <a:cs typeface="Be Vietnam Pro" pitchFamily="34" charset="-120"/>
-              </a:rPr>
-              <a:t>Thường được</a:t>
+              <a:rPr lang="en-US" sz="2400" dirty="0" spc="-13" kern="0">
+                <a:solidFill>
+                  <a:srgbClr val="14161C"/>
+                </a:solidFill>
+                <a:latin typeface="Be Vietnam Pro" pitchFamily="34" charset="0"/>
+                <a:ea typeface="Be Vietnam Pro" pitchFamily="34" charset="-122"/>
+                <a:cs typeface="Be Vietnam Pro" pitchFamily="34" charset="-120"/>
+              </a:rPr>
+              <a:t>Introduction</a:t>
             </a:r>
             <a:r>
               <a:rPr lang="en-US" sz="2400" dirty="0" spc="-14" kern="0">
@@ -11028,18 +11281,7 @@
                 <a:ea typeface="Be Vietnam Pro" pitchFamily="34" charset="-122"/>
                 <a:cs typeface="Be Vietnam Pro" pitchFamily="34" charset="-120"/>
               </a:rPr>
-              <a:t> xem</a:t>
-            </a:r>
-            <a:r>
-              <a:rPr lang="en-US" sz="2400" dirty="0" spc="-1" kern="0">
-                <a:solidFill>
-                  <a:srgbClr val="14161C"/>
-                </a:solidFill>
-                <a:latin typeface="Be Vietnam Pro" pitchFamily="34" charset="0"/>
-                <a:ea typeface="Be Vietnam Pro" pitchFamily="34" charset="-122"/>
-                <a:cs typeface="Be Vietnam Pro" pitchFamily="34" charset="-120"/>
-              </a:rPr>
-              <a:t> như “kinh</a:t>
+              <a:t> to</a:t>
             </a:r>
             <a:r>
               <a:rPr lang="en-US" sz="2400" dirty="0" spc="1" kern="0">
@@ -11050,7 +11292,29 @@
                 <a:ea typeface="Be Vietnam Pro" pitchFamily="34" charset="-122"/>
                 <a:cs typeface="Be Vietnam Pro" pitchFamily="34" charset="-120"/>
               </a:rPr>
-              <a:t> thánh”</a:t>
+              <a:t> Algorithms:</a:t>
+            </a:r>
+            <a:r>
+              <a:rPr lang="en-US" sz="2400" dirty="0" spc="3" kern="0">
+                <a:solidFill>
+                  <a:srgbClr val="14161C"/>
+                </a:solidFill>
+                <a:latin typeface="Be Vietnam Pro" pitchFamily="34" charset="0"/>
+                <a:ea typeface="Be Vietnam Pro" pitchFamily="34" charset="-122"/>
+                <a:cs typeface="Be Vietnam Pro" pitchFamily="34" charset="-120"/>
+              </a:rPr>
+              <a:t> giáo</a:t>
+            </a:r>
+            <a:r>
+              <a:rPr lang="en-US" sz="2400" dirty="0" spc="9" kern="0">
+                <a:solidFill>
+                  <a:srgbClr val="14161C"/>
+                </a:solidFill>
+                <a:latin typeface="Be Vietnam Pro" pitchFamily="34" charset="0"/>
+                <a:ea typeface="Be Vietnam Pro" pitchFamily="34" charset="-122"/>
+                <a:cs typeface="Be Vietnam Pro" pitchFamily="34" charset="-120"/>
+              </a:rPr>
+              <a:t> trình</a:t>
             </a:r>
             <a:endParaRPr lang="en-US" sz="2400" dirty="0"/>
           </a:p>
@@ -11067,81 +11331,70 @@
               <a:buChar char="•"/>
             </a:pPr>
             <a:r>
-              <a:rPr lang="en-US" sz="2400" dirty="0" spc="4" kern="0">
-                <a:solidFill>
-                  <a:srgbClr val="14161C"/>
-                </a:solidFill>
-                <a:latin typeface="Be Vietnam Pro" pitchFamily="34" charset="0"/>
-                <a:ea typeface="Be Vietnam Pro" pitchFamily="34" charset="-122"/>
-                <a:cs typeface="Be Vietnam Pro" pitchFamily="34" charset="-120"/>
-              </a:rPr>
-              <a:t>Bao</a:t>
-            </a:r>
-            <a:r>
-              <a:rPr lang="en-US" sz="2400" dirty="0" spc="-8" kern="0">
-                <a:solidFill>
-                  <a:srgbClr val="14161C"/>
-                </a:solidFill>
-                <a:latin typeface="Be Vietnam Pro" pitchFamily="34" charset="0"/>
-                <a:ea typeface="Be Vietnam Pro" pitchFamily="34" charset="-122"/>
-                <a:cs typeface="Be Vietnam Pro" pitchFamily="34" charset="-120"/>
-              </a:rPr>
-              <a:t> quát</a:t>
-            </a:r>
-            <a:r>
-              <a:rPr lang="en-US" sz="2400" dirty="0" spc="3" kern="0">
-                <a:solidFill>
-                  <a:srgbClr val="14161C"/>
-                </a:solidFill>
-                <a:latin typeface="Be Vietnam Pro" pitchFamily="34" charset="0"/>
-                <a:ea typeface="Be Vietnam Pro" pitchFamily="34" charset="-122"/>
-                <a:cs typeface="Be Vietnam Pro" pitchFamily="34" charset="-120"/>
-              </a:rPr>
-              <a:t> từ</a:t>
-            </a:r>
-            <a:r>
-              <a:rPr lang="en-US" sz="2400" dirty="0" spc="-4" kern="0">
-                <a:solidFill>
-                  <a:srgbClr val="14161C"/>
-                </a:solidFill>
-                <a:latin typeface="Be Vietnam Pro" pitchFamily="34" charset="0"/>
-                <a:ea typeface="Be Vietnam Pro" pitchFamily="34" charset="-122"/>
-                <a:cs typeface="Be Vietnam Pro" pitchFamily="34" charset="-120"/>
-              </a:rPr>
-              <a:t> thiết</a:t>
-            </a:r>
-            <a:r>
-              <a:rPr lang="en-US" sz="2400" dirty="0" spc="-27" kern="0">
-                <a:solidFill>
-                  <a:srgbClr val="14161C"/>
-                </a:solidFill>
-                <a:latin typeface="Be Vietnam Pro" pitchFamily="34" charset="0"/>
-                <a:ea typeface="Be Vietnam Pro" pitchFamily="34" charset="-122"/>
-                <a:cs typeface="Be Vietnam Pro" pitchFamily="34" charset="-120"/>
-              </a:rPr>
-              <a:t> kế,</a:t>
-            </a:r>
-            <a:r>
-              <a:rPr lang="en-US" sz="2400" dirty="0" spc="-6" kern="0">
-                <a:solidFill>
-                  <a:srgbClr val="14161C"/>
-                </a:solidFill>
-                <a:latin typeface="Be Vietnam Pro" pitchFamily="34" charset="0"/>
-                <a:ea typeface="Be Vietnam Pro" pitchFamily="34" charset="-122"/>
-                <a:cs typeface="Be Vietnam Pro" pitchFamily="34" charset="-120"/>
-              </a:rPr>
-              <a:t> viết</a:t>
-            </a:r>
-            <a:r>
-              <a:rPr lang="en-US" sz="2400" dirty="0" spc="4" kern="0">
-                <a:solidFill>
-                  <a:srgbClr val="14161C"/>
-                </a:solidFill>
-                <a:latin typeface="Be Vietnam Pro" pitchFamily="34" charset="0"/>
-                <a:ea typeface="Be Vietnam Pro" pitchFamily="34" charset="-122"/>
-                <a:cs typeface="Be Vietnam Pro" pitchFamily="34" charset="-120"/>
-              </a:rPr>
-              <a:t> mã</a:t>
+              <a:rPr lang="en-US" sz="2400" dirty="0" spc="-12" kern="0">
+                <a:solidFill>
+                  <a:srgbClr val="14161C"/>
+                </a:solidFill>
+                <a:latin typeface="Be Vietnam Pro" pitchFamily="34" charset="0"/>
+                <a:ea typeface="Be Vietnam Pro" pitchFamily="34" charset="-122"/>
+                <a:cs typeface="Be Vietnam Pro" pitchFamily="34" charset="-120"/>
+              </a:rPr>
+              <a:t>Cracking</a:t>
+            </a:r>
+            <a:r>
+              <a:rPr lang="en-US" sz="2400" dirty="0" spc="0" kern="0">
+                <a:solidFill>
+                  <a:srgbClr val="14161C"/>
+                </a:solidFill>
+                <a:latin typeface="Be Vietnam Pro" pitchFamily="34" charset="0"/>
+                <a:ea typeface="Be Vietnam Pro" pitchFamily="34" charset="-122"/>
+                <a:cs typeface="Be Vietnam Pro" pitchFamily="34" charset="-120"/>
+              </a:rPr>
+              <a:t> the</a:t>
+            </a:r>
+            <a:r>
+              <a:rPr lang="en-US" sz="2400" dirty="0" spc="-1" kern="0">
+                <a:solidFill>
+                  <a:srgbClr val="14161C"/>
+                </a:solidFill>
+                <a:latin typeface="Be Vietnam Pro" pitchFamily="34" charset="0"/>
+                <a:ea typeface="Be Vietnam Pro" pitchFamily="34" charset="-122"/>
+                <a:cs typeface="Be Vietnam Pro" pitchFamily="34" charset="-120"/>
+              </a:rPr>
+              <a:t> Coding</a:t>
+            </a:r>
+            <a:r>
+              <a:rPr lang="en-US" sz="2400" dirty="0" spc="-14" kern="0">
+                <a:solidFill>
+                  <a:srgbClr val="14161C"/>
+                </a:solidFill>
+                <a:latin typeface="Be Vietnam Pro" pitchFamily="34" charset="0"/>
+                <a:ea typeface="Be Vietnam Pro" pitchFamily="34" charset="-122"/>
+                <a:cs typeface="Be Vietnam Pro" pitchFamily="34" charset="-120"/>
+              </a:rPr>
+              <a:t> Interview:</a:t>
+            </a:r>
+            <a:r>
+              <a:rPr lang="en-US" sz="2400" dirty="0" spc="1" kern="0">
+                <a:solidFill>
+                  <a:srgbClr val="14161C"/>
+                </a:solidFill>
+                <a:latin typeface="Be Vietnam Pro" pitchFamily="34" charset="0"/>
+                <a:ea typeface="Be Vietnam Pro" pitchFamily="34" charset="-122"/>
+                <a:cs typeface="Be Vietnam Pro" pitchFamily="34" charset="-120"/>
+              </a:rPr>
+              <a:t> câu</a:t>
+            </a:r>
+            <a:r>
+              <a:rPr lang="en-US" sz="2400" dirty="0" spc="0" kern="0">
+                <a:solidFill>
+                  <a:srgbClr val="14161C"/>
+                </a:solidFill>
+                <a:latin typeface="Be Vietnam Pro" pitchFamily="34" charset="0"/>
+                <a:ea typeface="Be Vietnam Pro" pitchFamily="34" charset="-122"/>
+                <a:cs typeface="Be Vietnam Pro" pitchFamily="34" charset="-120"/>
+              </a:rPr>
+              <a:t> hỏi</a:t>
             </a:r>
             <a:endParaRPr lang="en-US" sz="2400" dirty="0"/>
           </a:p>
@@ -11155,37 +11408,26 @@
               <a:buChar char="•"/>
             </a:pPr>
             <a:r>
-              <a:rPr lang="en-US" sz="2400" dirty="0" spc="-73" kern="0">
-                <a:solidFill>
-                  <a:srgbClr val="14161C"/>
-                </a:solidFill>
-                <a:latin typeface="Be Vietnam Pro" pitchFamily="34" charset="0"/>
-                <a:ea typeface="Be Vietnam Pro" pitchFamily="34" charset="-122"/>
-                <a:cs typeface="Be Vietnam Pro" pitchFamily="34" charset="-120"/>
-              </a:rPr>
-              <a:t>Tới</a:t>
-            </a:r>
-            <a:r>
-              <a:rPr lang="en-US" sz="2400" dirty="0" spc="-1" kern="0">
-                <a:solidFill>
-                  <a:srgbClr val="14161C"/>
-                </a:solidFill>
-                <a:latin typeface="Be Vietnam Pro" pitchFamily="34" charset="0"/>
-                <a:ea typeface="Be Vietnam Pro" pitchFamily="34" charset="-122"/>
-                <a:cs typeface="Be Vietnam Pro" pitchFamily="34" charset="-120"/>
-              </a:rPr>
-              <a:t> kiểm</a:t>
-            </a:r>
-            <a:r>
-              <a:rPr lang="en-US" sz="2400" dirty="0" spc="3" kern="0">
-                <a:solidFill>
-                  <a:srgbClr val="14161C"/>
-                </a:solidFill>
-                <a:latin typeface="Be Vietnam Pro" pitchFamily="34" charset="0"/>
-                <a:ea typeface="Be Vietnam Pro" pitchFamily="34" charset="-122"/>
-                <a:cs typeface="Be Vietnam Pro" pitchFamily="34" charset="-120"/>
-              </a:rPr>
-              <a:t> thử</a:t>
+              <a:rPr lang="en-US" sz="2400" dirty="0" spc="0" kern="0">
+                <a:solidFill>
+                  <a:srgbClr val="14161C"/>
+                </a:solidFill>
+                <a:latin typeface="Be Vietnam Pro" pitchFamily="34" charset="0"/>
+                <a:ea typeface="Be Vietnam Pro" pitchFamily="34" charset="-122"/>
+                <a:cs typeface="Be Vietnam Pro" pitchFamily="34" charset="-120"/>
+              </a:rPr>
+              <a:t>Có lời</a:t>
+            </a:r>
+            <a:r>
+              <a:rPr lang="en-US" sz="2400" dirty="0" spc="1" kern="0">
+                <a:solidFill>
+                  <a:srgbClr val="14161C"/>
+                </a:solidFill>
+                <a:latin typeface="Be Vietnam Pro" pitchFamily="34" charset="0"/>
+                <a:ea typeface="Be Vietnam Pro" pitchFamily="34" charset="-122"/>
+                <a:cs typeface="Be Vietnam Pro" pitchFamily="34" charset="-120"/>
+              </a:rPr>
+              <a:t> giải</a:t>
             </a:r>
             <a:r>
               <a:rPr lang="en-US" sz="2400" dirty="0" spc="-16" kern="0">
@@ -11207,18 +11449,18 @@
                 <a:ea typeface="Be Vietnam Pro" pitchFamily="34" charset="-122"/>
                 <a:cs typeface="Be Vietnam Pro" pitchFamily="34" charset="-120"/>
               </a:rPr>
-              <a:t> bảo</a:t>
-            </a:r>
-            <a:r>
-              <a:rPr lang="en-US" sz="2400" dirty="0" spc="14" kern="0">
-                <a:solidFill>
-                  <a:srgbClr val="14161C"/>
-                </a:solidFill>
-                <a:latin typeface="Be Vietnam Pro" pitchFamily="34" charset="0"/>
-                <a:ea typeface="Be Vietnam Pro" pitchFamily="34" charset="-122"/>
-                <a:cs typeface="Be Vietnam Pro" pitchFamily="34" charset="-120"/>
-              </a:rPr>
-              <a:t> trì</a:t>
+              <a:t> cách</a:t>
+            </a:r>
+            <a:r>
+              <a:rPr lang="en-US" sz="2400" dirty="0" spc="-15" kern="0">
+                <a:solidFill>
+                  <a:srgbClr val="14161C"/>
+                </a:solidFill>
+                <a:latin typeface="Be Vietnam Pro" pitchFamily="34" charset="0"/>
+                <a:ea typeface="Be Vietnam Pro" pitchFamily="34" charset="-122"/>
+                <a:cs typeface="Be Vietnam Pro" pitchFamily="34" charset="-120"/>
+              </a:rPr>
+              <a:t> luyện</a:t>
             </a:r>
             <a:endParaRPr lang="en-US" sz="2400" dirty="0"/>
           </a:p>
@@ -11759,7 +12001,7 @@
               <a:buNone/>
             </a:pPr>
             <a:r>
-              <a:rPr lang="en-US" sz="2850" dirty="0" spc="-3" kern="0">
+              <a:rPr lang="en-US" sz="2850" dirty="0" spc="1" kern="0">
                 <a:solidFill>
                   <a:srgbClr val="C4C8D6"/>
                 </a:solidFill>
@@ -11767,10 +12009,10 @@
                 <a:ea typeface="Be Vietnam Pro" pitchFamily="34" charset="-122"/>
                 <a:cs typeface="Be Vietnam Pro" pitchFamily="34" charset="-120"/>
               </a:rPr>
-              <a:t>Nguồn</a:t>
-            </a:r>
-            <a:r>
-              <a:rPr lang="en-US" sz="2850" dirty="0" spc="-15" kern="0">
+              <a:t>Mô</a:t>
+            </a:r>
+            <a:r>
+              <a:rPr lang="en-US" sz="2850" dirty="0" spc="-19" kern="0">
                 <a:solidFill>
                   <a:srgbClr val="C4C8D6"/>
                 </a:solidFill>
@@ -11778,7 +12020,40 @@
                 <a:ea typeface="Be Vietnam Pro" pitchFamily="34" charset="-122"/>
                 <a:cs typeface="Be Vietnam Pro" pitchFamily="34" charset="-120"/>
               </a:rPr>
-              <a:t> gần</a:t>
+              <a:t> tả</a:t>
+            </a:r>
+            <a:r>
+              <a:rPr lang="en-US" sz="2850" dirty="0" spc="20" kern="0">
+                <a:solidFill>
+                  <a:srgbClr val="C4C8D6"/>
+                </a:solidFill>
+                <a:latin typeface="Be Vietnam Pro" pitchFamily="34" charset="0"/>
+                <a:ea typeface="Be Vietnam Pro" pitchFamily="34" charset="-122"/>
+                <a:cs typeface="Be Vietnam Pro" pitchFamily="34" charset="-120"/>
+              </a:rPr>
+              <a:t> từng</a:t>
+            </a:r>
+            <a:r>
+              <a:rPr lang="en-US" sz="2850" dirty="0" spc="-1" kern="0">
+                <a:solidFill>
+                  <a:srgbClr val="C4C8D6"/>
+                </a:solidFill>
+                <a:latin typeface="Be Vietnam Pro" pitchFamily="34" charset="0"/>
+                <a:ea typeface="Be Vietnam Pro" pitchFamily="34" charset="-122"/>
+                <a:cs typeface="Be Vietnam Pro" pitchFamily="34" charset="-120"/>
+              </a:rPr>
+              <a:t> cuốn</a:t>
+            </a:r>
+            <a:r>
+              <a:rPr lang="en-US" sz="2850" dirty="0" spc="2" kern="0">
+                <a:solidFill>
+                  <a:srgbClr val="C4C8D6"/>
+                </a:solidFill>
+                <a:latin typeface="Be Vietnam Pro" pitchFamily="34" charset="0"/>
+                <a:ea typeface="Be Vietnam Pro" pitchFamily="34" charset="-122"/>
+                <a:cs typeface="Be Vietnam Pro" pitchFamily="34" charset="-120"/>
+              </a:rPr>
+              <a:t> là</a:t>
             </a:r>
             <a:r>
               <a:rPr lang="en-US" sz="2850" dirty="0" spc="1" kern="0">
@@ -11789,7 +12064,51 @@
                 <a:ea typeface="Be Vietnam Pro" pitchFamily="34" charset="-122"/>
                 <a:cs typeface="Be Vietnam Pro" pitchFamily="34" charset="-120"/>
               </a:rPr>
-              <a:t> như</a:t>
+              <a:t> hiểu</a:t>
+            </a:r>
+            <a:r>
+              <a:rPr lang="en-US" sz="2850" dirty="0" spc="-6" kern="0">
+                <a:solidFill>
+                  <a:srgbClr val="C4C8D6"/>
+                </a:solidFill>
+                <a:latin typeface="Be Vietnam Pro" pitchFamily="34" charset="0"/>
+                <a:ea typeface="Be Vietnam Pro" pitchFamily="34" charset="-122"/>
+                <a:cs typeface="Be Vietnam Pro" pitchFamily="34" charset="-120"/>
+              </a:rPr>
+              <a:t> biết</a:t>
+            </a:r>
+            <a:r>
+              <a:rPr lang="en-US" sz="2850" dirty="0" spc="-1" kern="0">
+                <a:solidFill>
+                  <a:srgbClr val="C4C8D6"/>
+                </a:solidFill>
+                <a:latin typeface="Be Vietnam Pro" pitchFamily="34" charset="0"/>
+                <a:ea typeface="Be Vietnam Pro" pitchFamily="34" charset="-122"/>
+                <a:cs typeface="Be Vietnam Pro" pitchFamily="34" charset="-120"/>
+              </a:rPr>
+              <a:t> chung,</a:t>
+            </a:r>
+            <a:r>
+              <a:rPr lang="en-US" sz="2850" dirty="0" spc="10" kern="0">
+                <a:solidFill>
+                  <a:srgbClr val="C4C8D6"/>
+                </a:solidFill>
+                <a:latin typeface="Be Vietnam Pro" pitchFamily="34" charset="0"/>
+                <a:ea typeface="Be Vietnam Pro" pitchFamily="34" charset="-122"/>
+                <a:cs typeface="Be Vietnam Pro" pitchFamily="34" charset="-120"/>
+              </a:rPr>
+              <a:t> chưa</a:t>
+            </a:r>
+            <a:r>
+              <a:rPr lang="en-US" sz="2850" dirty="0" spc="16" kern="0">
+                <a:solidFill>
+                  <a:srgbClr val="C4C8D6"/>
+                </a:solidFill>
+                <a:latin typeface="Be Vietnam Pro" pitchFamily="34" charset="0"/>
+                <a:ea typeface="Be Vietnam Pro" pitchFamily="34" charset="-122"/>
+                <a:cs typeface="Be Vietnam Pro" pitchFamily="34" charset="-120"/>
+              </a:rPr>
+              <a:t> đối</a:t>
             </a:r>
             <a:r>
               <a:rPr lang="en-US" sz="2850" dirty="0" spc="0" kern="0">
@@ -11800,117 +12119,7 @@
                 <a:ea typeface="Be Vietnam Pro" pitchFamily="34" charset="-122"/>
                 <a:cs typeface="Be Vietnam Pro" pitchFamily="34" charset="-120"/>
               </a:rPr>
-              <a:t> chỉ</a:t>
-            </a:r>
-            <a:r>
-              <a:rPr lang="en-US" sz="2850" dirty="0" spc="-5" kern="0">
-                <a:solidFill>
-                  <a:srgbClr val="C4C8D6"/>
-                </a:solidFill>
-                <a:latin typeface="Be Vietnam Pro" pitchFamily="34" charset="0"/>
-                <a:ea typeface="Be Vietnam Pro" pitchFamily="34" charset="-122"/>
-                <a:cs typeface="Be Vietnam Pro" pitchFamily="34" charset="-120"/>
-              </a:rPr>
-              <a:t> liệt</a:t>
-            </a:r>
-            <a:r>
-              <a:rPr lang="en-US" sz="2850" dirty="0" spc="-33" kern="0">
-                <a:solidFill>
-                  <a:srgbClr val="C4C8D6"/>
-                </a:solidFill>
-                <a:latin typeface="Be Vietnam Pro" pitchFamily="34" charset="0"/>
-                <a:ea typeface="Be Vietnam Pro" pitchFamily="34" charset="-122"/>
-                <a:cs typeface="Be Vietnam Pro" pitchFamily="34" charset="-120"/>
-              </a:rPr>
-              <a:t> kê,</a:t>
-            </a:r>
-            <a:r>
-              <a:rPr lang="en-US" sz="2850" dirty="0" spc="-16" kern="0">
-                <a:solidFill>
-                  <a:srgbClr val="C4C8D6"/>
-                </a:solidFill>
-                <a:latin typeface="Be Vietnam Pro" pitchFamily="34" charset="0"/>
-                <a:ea typeface="Be Vietnam Pro" pitchFamily="34" charset="-122"/>
-                <a:cs typeface="Be Vietnam Pro" pitchFamily="34" charset="-120"/>
-              </a:rPr>
-              <a:t> và</a:t>
-            </a:r>
-            <a:r>
-              <a:rPr lang="en-US" sz="2850" dirty="0" spc="-3" kern="0">
-                <a:solidFill>
-                  <a:srgbClr val="C4C8D6"/>
-                </a:solidFill>
-                <a:latin typeface="Be Vietnam Pro" pitchFamily="34" charset="0"/>
-                <a:ea typeface="Be Vietnam Pro" pitchFamily="34" charset="-122"/>
-                <a:cs typeface="Be Vietnam Pro" pitchFamily="34" charset="-120"/>
-              </a:rPr>
-              <a:t> bài</a:t>
-            </a:r>
-            <a:r>
-              <a:rPr lang="en-US" sz="2850" dirty="0" spc="-2" kern="0">
-                <a:solidFill>
-                  <a:srgbClr val="C4C8D6"/>
-                </a:solidFill>
-                <a:latin typeface="Be Vietnam Pro" pitchFamily="34" charset="0"/>
-                <a:ea typeface="Be Vietnam Pro" pitchFamily="34" charset="-122"/>
-                <a:cs typeface="Be Vietnam Pro" pitchFamily="34" charset="-120"/>
-              </a:rPr>
-              <a:t> không</a:t>
-            </a:r>
-            <a:r>
-              <a:rPr lang="en-US" sz="2850" dirty="0" spc="10" kern="0">
-                <a:solidFill>
-                  <a:srgbClr val="C4C8D6"/>
-                </a:solidFill>
-                <a:latin typeface="Be Vietnam Pro" pitchFamily="34" charset="0"/>
-                <a:ea typeface="Be Vietnam Pro" pitchFamily="34" charset="-122"/>
-                <a:cs typeface="Be Vietnam Pro" pitchFamily="34" charset="-120"/>
-              </a:rPr>
-              <a:t> đánh</a:t>
-            </a:r>
-            <a:r>
-              <a:rPr lang="en-US" sz="2850" dirty="0" spc="1" kern="0">
-                <a:solidFill>
-                  <a:srgbClr val="C4C8D6"/>
-                </a:solidFill>
-                <a:latin typeface="Be Vietnam Pro" pitchFamily="34" charset="0"/>
-                <a:ea typeface="Be Vietnam Pro" pitchFamily="34" charset="-122"/>
-                <a:cs typeface="Be Vietnam Pro" pitchFamily="34" charset="-120"/>
-              </a:rPr>
-              <a:t> giá</a:t>
-            </a:r>
-            <a:r>
-              <a:rPr lang="en-US" sz="2850" dirty="0" spc="0" kern="0">
-                <a:solidFill>
-                  <a:srgbClr val="C4C8D6"/>
-                </a:solidFill>
-                <a:latin typeface="Be Vietnam Pro" pitchFamily="34" charset="0"/>
-                <a:ea typeface="Be Vietnam Pro" pitchFamily="34" charset="-122"/>
-                <a:cs typeface="Be Vietnam Pro" pitchFamily="34" charset="-120"/>
-              </a:rPr>
-              <a:t> nội</a:t>
-            </a:r>
-            <a:r>
-              <a:rPr lang="en-US" sz="2850" dirty="0" spc="-2" kern="0">
-                <a:solidFill>
-                  <a:srgbClr val="C4C8D6"/>
-                </a:solidFill>
-                <a:latin typeface="Be Vietnam Pro" pitchFamily="34" charset="0"/>
-                <a:ea typeface="Be Vietnam Pro" pitchFamily="34" charset="-122"/>
-                <a:cs typeface="Be Vietnam Pro" pitchFamily="34" charset="-120"/>
-              </a:rPr>
-              <a:t> dung</a:t>
-            </a:r>
-            <a:r>
-              <a:rPr lang="en-US" sz="2850" dirty="0" spc="-4" kern="0">
-                <a:solidFill>
-                  <a:srgbClr val="C4C8D6"/>
-                </a:solidFill>
-                <a:latin typeface="Be Vietnam Pro" pitchFamily="34" charset="0"/>
-                <a:ea typeface="Be Vietnam Pro" pitchFamily="34" charset="-122"/>
-                <a:cs typeface="Be Vietnam Pro" pitchFamily="34" charset="-120"/>
-              </a:rPr>
-              <a:t> sách.</a:t>
+              <a:t> chiếu.</a:t>
             </a:r>
             <a:endParaRPr lang="en-US" sz="2850" dirty="0"/>
           </a:p>
@@ -13661,7 +13870,106 @@
                 <a:ea typeface="Be Vietnam Pro" pitchFamily="34" charset="-122"/>
                 <a:cs typeface="Be Vietnam Pro" pitchFamily="34" charset="-120"/>
               </a:rPr>
-              <a:t>Cuốn Clean Code</a:t>
+              <a:t>Cuốn</a:t>
+            </a:r>
+            <a:r>
+              <a:rPr lang="en-US" sz="2850" dirty="0" spc="1" kern="0">
+                <a:solidFill>
+                  <a:srgbClr val="14161C"/>
+                </a:solidFill>
+                <a:latin typeface="Be Vietnam Pro" pitchFamily="34" charset="0"/>
+                <a:ea typeface="Be Vietnam Pro" pitchFamily="34" charset="-122"/>
+                <a:cs typeface="Be Vietnam Pro" pitchFamily="34" charset="-120"/>
+              </a:rPr>
+              <a:t> nào</a:t>
+            </a:r>
+            <a:r>
+              <a:rPr lang="en-US" sz="2850" dirty="0" spc="-11" kern="0">
+                <a:solidFill>
+                  <a:srgbClr val="14161C"/>
+                </a:solidFill>
+                <a:latin typeface="Be Vietnam Pro" pitchFamily="34" charset="0"/>
+                <a:ea typeface="Be Vietnam Pro" pitchFamily="34" charset="-122"/>
+                <a:cs typeface="Be Vietnam Pro" pitchFamily="34" charset="-120"/>
+              </a:rPr>
+              <a:t> dạy</a:t>
+            </a:r>
+            <a:r>
+              <a:rPr lang="en-US" sz="2850" dirty="0" spc="12" kern="0">
+                <a:solidFill>
+                  <a:srgbClr val="14161C"/>
+                </a:solidFill>
+                <a:latin typeface="Be Vietnam Pro" pitchFamily="34" charset="0"/>
+                <a:ea typeface="Be Vietnam Pro" pitchFamily="34" charset="-122"/>
+                <a:cs typeface="Be Vietnam Pro" pitchFamily="34" charset="-120"/>
+              </a:rPr>
+              <a:t> sửa</a:t>
+            </a:r>
+            <a:r>
+              <a:rPr lang="en-US" sz="2850" dirty="0" spc="0" kern="0">
+                <a:solidFill>
+                  <a:srgbClr val="14161C"/>
+                </a:solidFill>
+                <a:latin typeface="Be Vietnam Pro" pitchFamily="34" charset="0"/>
+                <a:ea typeface="Be Vietnam Pro" pitchFamily="34" charset="-122"/>
+                <a:cs typeface="Be Vietnam Pro" pitchFamily="34" charset="-120"/>
+              </a:rPr>
+              <a:t> mã</a:t>
+            </a:r>
+            <a:r>
+              <a:rPr lang="en-US" sz="2850" dirty="0" spc="-5" kern="0">
+                <a:solidFill>
+                  <a:srgbClr val="14161C"/>
+                </a:solidFill>
+                <a:latin typeface="Be Vietnam Pro" pitchFamily="34" charset="0"/>
+                <a:ea typeface="Be Vietnam Pro" pitchFamily="34" charset="-122"/>
+                <a:cs typeface="Be Vietnam Pro" pitchFamily="34" charset="-120"/>
+              </a:rPr>
+              <a:t> bằng</a:t>
+            </a:r>
+            <a:r>
+              <a:rPr lang="en-US" sz="2850" dirty="0" spc="8" kern="0">
+                <a:solidFill>
+                  <a:srgbClr val="14161C"/>
+                </a:solidFill>
+                <a:latin typeface="Be Vietnam Pro" pitchFamily="34" charset="0"/>
+                <a:ea typeface="Be Vietnam Pro" pitchFamily="34" charset="-122"/>
+                <a:cs typeface="Be Vietnam Pro" pitchFamily="34" charset="-120"/>
+              </a:rPr>
+              <a:t> bước</a:t>
+            </a:r>
+            <a:r>
+              <a:rPr lang="en-US" sz="2850" dirty="0" spc="0" kern="0">
+                <a:solidFill>
+                  <a:srgbClr val="14161C"/>
+                </a:solidFill>
+                <a:latin typeface="Be Vietnam Pro" pitchFamily="34" charset="0"/>
+                <a:ea typeface="Be Vietnam Pro" pitchFamily="34" charset="-122"/>
+                <a:cs typeface="Be Vietnam Pro" pitchFamily="34" charset="-120"/>
+              </a:rPr>
+              <a:t> nhỏ,</a:t>
+            </a:r>
+            <a:r>
+              <a:rPr lang="en-US" sz="2850" dirty="0" spc="-17" kern="0">
+                <a:solidFill>
+                  <a:srgbClr val="14161C"/>
+                </a:solidFill>
+                <a:latin typeface="Be Vietnam Pro" pitchFamily="34" charset="0"/>
+                <a:ea typeface="Be Vietnam Pro" pitchFamily="34" charset="-122"/>
+                <a:cs typeface="Be Vietnam Pro" pitchFamily="34" charset="-120"/>
+              </a:rPr>
+              <a:t> và</a:t>
+            </a:r>
+            <a:r>
+              <a:rPr lang="en-US" sz="2850" dirty="0" spc="-4" kern="0">
+                <a:solidFill>
+                  <a:srgbClr val="14161C"/>
+                </a:solidFill>
+                <a:latin typeface="Be Vietnam Pro" pitchFamily="34" charset="0"/>
+                <a:ea typeface="Be Vietnam Pro" pitchFamily="34" charset="-122"/>
+                <a:cs typeface="Be Vietnam Pro" pitchFamily="34" charset="-120"/>
+              </a:rPr>
+              <a:t> thuộc</a:t>
             </a:r>
             <a:r>
               <a:rPr lang="en-US" sz="2850" dirty="0" spc="-1" kern="0">
@@ -13672,7 +13980,7 @@
                 <a:ea typeface="Be Vietnam Pro" pitchFamily="34" charset="-122"/>
                 <a:cs typeface="Be Vietnam Pro" pitchFamily="34" charset="-120"/>
               </a:rPr>
-              <a:t> nằm</a:t>
+              <a:t> nhóm</a:t>
             </a:r>
             <a:r>
               <a:rPr lang="en-US" sz="2850" dirty="0" spc="0" kern="0">
@@ -13683,62 +13991,7 @@
                 <a:ea typeface="Be Vietnam Pro" pitchFamily="34" charset="-122"/>
                 <a:cs typeface="Be Vietnam Pro" pitchFamily="34" charset="-120"/>
               </a:rPr>
-              <a:t> ở</a:t>
-            </a:r>
-            <a:r>
-              <a:rPr lang="en-US" sz="2850" dirty="0" spc="-2" kern="0">
-                <a:solidFill>
-                  <a:srgbClr val="14161C"/>
-                </a:solidFill>
-                <a:latin typeface="Be Vietnam Pro" pitchFamily="34" charset="0"/>
-                <a:ea typeface="Be Vietnam Pro" pitchFamily="34" charset="-122"/>
-                <a:cs typeface="Be Vietnam Pro" pitchFamily="34" charset="-120"/>
-              </a:rPr>
-              <a:t> nhóm</a:t>
-            </a:r>
-            <a:r>
-              <a:rPr lang="en-US" sz="2850" dirty="0" spc="1" kern="0">
-                <a:solidFill>
-                  <a:srgbClr val="14161C"/>
-                </a:solidFill>
-                <a:latin typeface="Be Vietnam Pro" pitchFamily="34" charset="0"/>
-                <a:ea typeface="Be Vietnam Pro" pitchFamily="34" charset="-122"/>
-                <a:cs typeface="Be Vietnam Pro" pitchFamily="34" charset="-120"/>
-              </a:rPr>
-              <a:t> nào</a:t>
-            </a:r>
-            <a:r>
-              <a:rPr lang="en-US" sz="2850" dirty="0" spc="-16" kern="0">
-                <a:solidFill>
-                  <a:srgbClr val="14161C"/>
-                </a:solidFill>
-                <a:latin typeface="Be Vietnam Pro" pitchFamily="34" charset="0"/>
-                <a:ea typeface="Be Vietnam Pro" pitchFamily="34" charset="-122"/>
-                <a:cs typeface="Be Vietnam Pro" pitchFamily="34" charset="-120"/>
-              </a:rPr>
-              <a:t> và</a:t>
-            </a:r>
-            <a:r>
-              <a:rPr lang="en-US" sz="2850" dirty="0" spc="1" kern="0">
-                <a:solidFill>
-                  <a:srgbClr val="14161C"/>
-                </a:solidFill>
-                <a:latin typeface="Be Vietnam Pro" pitchFamily="34" charset="0"/>
-                <a:ea typeface="Be Vietnam Pro" pitchFamily="34" charset="-122"/>
-                <a:cs typeface="Be Vietnam Pro" pitchFamily="34" charset="-120"/>
-              </a:rPr>
-              <a:t> của</a:t>
-            </a:r>
-            <a:r>
-              <a:rPr lang="en-US" sz="2850" dirty="0" spc="2" kern="0">
-                <a:solidFill>
-                  <a:srgbClr val="14161C"/>
-                </a:solidFill>
-                <a:latin typeface="Be Vietnam Pro" pitchFamily="34" charset="0"/>
-                <a:ea typeface="Be Vietnam Pro" pitchFamily="34" charset="-122"/>
-                <a:cs typeface="Be Vietnam Pro" pitchFamily="34" charset="-120"/>
-              </a:rPr>
-              <a:t> ai?</a:t>
+              <a:t> nào?</a:t>
             </a:r>
             <a:endParaRPr lang="en-US" sz="2850" dirty="0"/>
           </a:p>
@@ -14127,7 +14380,7 @@
               <a:buNone/>
             </a:pPr>
             <a:r>
-              <a:rPr lang="en-US" sz="2100" dirty="0" spc="-3" kern="0">
+              <a:rPr lang="en-US" sz="2100" dirty="0" spc="-15" kern="0">
                 <a:solidFill>
                   <a:srgbClr val="55544F"/>
                 </a:solidFill>
@@ -14135,7 +14388,7 @@
                 <a:ea typeface="Be Vietnam Pro" pitchFamily="34" charset="-122"/>
                 <a:cs typeface="Be Vietnam Pro" pitchFamily="34" charset="-120"/>
               </a:rPr>
-              <a:t>Clean</a:t>
+              <a:t>Refactoring</a:t>
             </a:r>
             <a:r>
               <a:rPr lang="en-US" sz="2100" dirty="0" spc="-5" kern="0">
@@ -14146,21 +14399,10 @@
                 <a:ea typeface="Be Vietnam Pro" pitchFamily="34" charset="-122"/>
                 <a:cs typeface="Be Vietnam Pro" pitchFamily="34" charset="-120"/>
               </a:rPr>
-              <a:t> Code</a:t>
-            </a:r>
-            <a:r>
-              <a:rPr lang="en-US" sz="2100" dirty="0" spc="-3" kern="0">
-                <a:solidFill>
-                  <a:srgbClr val="55544F"/>
-                </a:solidFill>
-                <a:latin typeface="Be Vietnam Pro" pitchFamily="34" charset="0"/>
-                <a:ea typeface="Be Vietnam Pro" pitchFamily="34" charset="-122"/>
-                <a:cs typeface="Be Vietnam Pro" pitchFamily="34" charset="-120"/>
-              </a:rPr>
               <a:t> thuộc</a:t>
             </a:r>
             <a:r>
-              <a:rPr lang="en-US" sz="2100" dirty="0" spc="-2" kern="0">
+              <a:rPr lang="en-US" sz="2100" dirty="0" spc="-1" kern="0">
                 <a:solidFill>
                   <a:srgbClr val="55544F"/>
                 </a:solidFill>
@@ -14308,28 +14550,6 @@
               <a:buNone/>
             </a:pPr>
             <a:r>
-              <a:rPr lang="en-US" sz="2850" b="1" dirty="0" spc="-26" kern="0">
-                <a:solidFill>
-                  <a:srgbClr val="14161C"/>
-                </a:solidFill>
-                <a:latin typeface="Be Vietnam Pro" pitchFamily="34" charset="0"/>
-                <a:ea typeface="Be Vietnam Pro" pitchFamily="34" charset="-122"/>
-                <a:cs typeface="Be Vietnam Pro" pitchFamily="34" charset="-120"/>
-              </a:rPr>
-              <a:t>Robert</a:t>
-            </a:r>
-            <a:r>
-              <a:rPr lang="en-US" sz="2850" b="1" dirty="0" spc="4" kern="0">
-                <a:solidFill>
-                  <a:srgbClr val="14161C"/>
-                </a:solidFill>
-                <a:latin typeface="Be Vietnam Pro" pitchFamily="34" charset="0"/>
-                <a:ea typeface="Be Vietnam Pro" pitchFamily="34" charset="-122"/>
-                <a:cs typeface="Be Vietnam Pro" pitchFamily="34" charset="-120"/>
-              </a:rPr>
-              <a:t> C.</a:t>
-            </a:r>
-            <a:r>
               <a:rPr lang="en-US" sz="2850" b="1" dirty="0" spc="2" kern="0">
                 <a:solidFill>
                   <a:srgbClr val="14161C"/>
@@ -14338,7 +14558,18 @@
                 <a:ea typeface="Be Vietnam Pro" pitchFamily="34" charset="-122"/>
                 <a:cs typeface="Be Vietnam Pro" pitchFamily="34" charset="-120"/>
               </a:rPr>
-              <a:t> Martin</a:t>
+              <a:t>Martin</a:t>
+            </a:r>
+            <a:r>
+              <a:rPr lang="en-US" sz="2850" b="1" dirty="0" spc="-37" kern="0">
+                <a:solidFill>
+                  <a:srgbClr val="14161C"/>
+                </a:solidFill>
+                <a:latin typeface="Be Vietnam Pro" pitchFamily="34" charset="0"/>
+                <a:ea typeface="Be Vietnam Pro" pitchFamily="34" charset="-122"/>
+                <a:cs typeface="Be Vietnam Pro" pitchFamily="34" charset="-120"/>
+              </a:rPr>
+              <a:t> Fowler</a:t>
             </a:r>
             <a:endParaRPr lang="en-US" sz="2850" dirty="0"/>
           </a:p>
@@ -14394,7 +14625,7 @@
               <a:t> giả của</a:t>
             </a:r>
             <a:r>
-              <a:rPr lang="en-US" sz="2100" dirty="0" spc="-3" kern="0">
+              <a:rPr lang="en-US" sz="2100" dirty="0" spc="-13" kern="0">
                 <a:solidFill>
                   <a:srgbClr val="55544F"/>
                 </a:solidFill>
@@ -14402,18 +14633,7 @@
                 <a:ea typeface="Be Vietnam Pro" pitchFamily="34" charset="-122"/>
                 <a:cs typeface="Be Vietnam Pro" pitchFamily="34" charset="-120"/>
               </a:rPr>
-              <a:t> Clean</a:t>
-            </a:r>
-            <a:r>
-              <a:rPr lang="en-US" sz="2100" dirty="0" spc="-4" kern="0">
-                <a:solidFill>
-                  <a:srgbClr val="55544F"/>
-                </a:solidFill>
-                <a:latin typeface="Be Vietnam Pro" pitchFamily="34" charset="0"/>
-                <a:ea typeface="Be Vietnam Pro" pitchFamily="34" charset="-122"/>
-                <a:cs typeface="Be Vietnam Pro" pitchFamily="34" charset="-120"/>
-              </a:rPr>
-              <a:t> Code.</a:t>
+              <a:t> Refactoring.</a:t>
             </a:r>
             <a:endParaRPr lang="en-US" sz="2100" dirty="0"/>
           </a:p>
@@ -15519,7 +15739,7 @@
               <a:buNone/>
             </a:pPr>
             <a:r>
-              <a:rPr lang="en-US" sz="2550" b="1" dirty="0" spc="-11" kern="0">
+              <a:rPr lang="en-US" sz="2550" b="1" dirty="0" spc="-2" kern="0">
                 <a:solidFill>
                   <a:srgbClr val="F3EEE3"/>
                 </a:solidFill>
@@ -15527,10 +15747,10 @@
                 <a:ea typeface="Be Vietnam Pro" pitchFamily="34" charset="-122"/>
                 <a:cs typeface="Be Vietnam Pro" pitchFamily="34" charset="-120"/>
               </a:rPr>
-              <a:t>Một</a:t>
-            </a:r>
-            <a:r>
-              <a:rPr lang="en-US" sz="2550" b="1" dirty="0" spc="-2" kern="0">
+              <a:t>Mỗi cuốn</a:t>
+            </a:r>
+            <a:r>
+              <a:rPr lang="en-US" sz="2550" b="1" dirty="0" spc="-9" kern="0">
                 <a:solidFill>
                   <a:srgbClr val="F3EEE3"/>
                 </a:solidFill>
@@ -15538,10 +15758,10 @@
                 <a:ea typeface="Be Vietnam Pro" pitchFamily="34" charset="-122"/>
                 <a:cs typeface="Be Vietnam Pro" pitchFamily="34" charset="-120"/>
               </a:rPr>
-              <a:t> cuốn</a:t>
-            </a:r>
-            <a:r>
-              <a:rPr lang="en-US" sz="2550" b="1" dirty="0" spc="-3" kern="0">
+              <a:t> một</a:t>
+            </a:r>
+            <a:r>
+              <a:rPr lang="en-US" sz="2550" b="1" dirty="0" spc="-1" kern="0">
                 <a:solidFill>
                   <a:srgbClr val="F3EEE3"/>
                 </a:solidFill>
@@ -15549,29 +15769,7 @@
                 <a:ea typeface="Be Vietnam Pro" pitchFamily="34" charset="-122"/>
                 <a:cs typeface="Be Vietnam Pro" pitchFamily="34" charset="-120"/>
               </a:rPr>
-              <a:t> có</a:t>
-            </a:r>
-            <a:r>
-              <a:rPr lang="en-US" sz="2550" b="1" dirty="0" spc="3" kern="0">
-                <a:solidFill>
-                  <a:srgbClr val="F3EEE3"/>
-                </a:solidFill>
-                <a:latin typeface="Be Vietnam Pro" pitchFamily="34" charset="0"/>
-                <a:ea typeface="Be Vietnam Pro" pitchFamily="34" charset="-122"/>
-                <a:cs typeface="Be Vietnam Pro" pitchFamily="34" charset="-120"/>
-              </a:rPr>
-              <a:t> lời</a:t>
-            </a:r>
-            <a:r>
-              <a:rPr lang="en-US" sz="2550" b="1" dirty="0" spc="-5" kern="0">
-                <a:solidFill>
-                  <a:srgbClr val="F3EEE3"/>
-                </a:solidFill>
-                <a:latin typeface="Be Vietnam Pro" pitchFamily="34" charset="0"/>
-                <a:ea typeface="Be Vietnam Pro" pitchFamily="34" charset="-122"/>
-                <a:cs typeface="Be Vietnam Pro" pitchFamily="34" charset="-120"/>
-              </a:rPr>
-              <a:t> mô tả</a:t>
+              <a:t> việc</a:t>
             </a:r>
             <a:endParaRPr lang="en-US" sz="2550" dirty="0"/>
           </a:p>
@@ -15602,6 +15800,61 @@
               <a:buNone/>
             </a:pPr>
             <a:r>
+              <a:rPr lang="en-US" sz="2100" dirty="0" spc="-1" kern="0">
+                <a:solidFill>
+                  <a:srgbClr val="C4C8D6"/>
+                </a:solidFill>
+                <a:latin typeface="Be Vietnam Pro" pitchFamily="34" charset="0"/>
+                <a:ea typeface="Be Vietnam Pro" pitchFamily="34" charset="-122"/>
+                <a:cs typeface="Be Vietnam Pro" pitchFamily="34" charset="-120"/>
+              </a:rPr>
+              <a:t>Mô</a:t>
+            </a:r>
+            <a:r>
+              <a:rPr lang="en-US" sz="2100" dirty="0" spc="-17" kern="0">
+                <a:solidFill>
+                  <a:srgbClr val="C4C8D6"/>
+                </a:solidFill>
+                <a:latin typeface="Be Vietnam Pro" pitchFamily="34" charset="0"/>
+                <a:ea typeface="Be Vietnam Pro" pitchFamily="34" charset="-122"/>
+                <a:cs typeface="Be Vietnam Pro" pitchFamily="34" charset="-120"/>
+              </a:rPr>
+              <a:t> tả</a:t>
+            </a:r>
+            <a:r>
+              <a:rPr lang="en-US" sz="2100" dirty="0" spc="-4" kern="0">
+                <a:solidFill>
+                  <a:srgbClr val="C4C8D6"/>
+                </a:solidFill>
+                <a:latin typeface="Be Vietnam Pro" pitchFamily="34" charset="0"/>
+                <a:ea typeface="Be Vietnam Pro" pitchFamily="34" charset="-122"/>
+                <a:cs typeface="Be Vietnam Pro" pitchFamily="34" charset="-120"/>
+              </a:rPr>
+              <a:t> là</a:t>
+            </a:r>
+            <a:r>
+              <a:rPr lang="en-US" sz="2100" dirty="0" spc="1" kern="0">
+                <a:solidFill>
+                  <a:srgbClr val="C4C8D6"/>
+                </a:solidFill>
+                <a:latin typeface="Be Vietnam Pro" pitchFamily="34" charset="0"/>
+                <a:ea typeface="Be Vietnam Pro" pitchFamily="34" charset="-122"/>
+                <a:cs typeface="Be Vietnam Pro" pitchFamily="34" charset="-120"/>
+              </a:rPr>
+              <a:t> hiểu</a:t>
+            </a:r>
+            <a:r>
+              <a:rPr lang="en-US" sz="2100" dirty="0" spc="-5" kern="0">
+                <a:solidFill>
+                  <a:srgbClr val="C4C8D6"/>
+                </a:solidFill>
+                <a:latin typeface="Be Vietnam Pro" pitchFamily="34" charset="0"/>
+                <a:ea typeface="Be Vietnam Pro" pitchFamily="34" charset="-122"/>
+                <a:cs typeface="Be Vietnam Pro" pitchFamily="34" charset="-120"/>
+              </a:rPr>
+              <a:t> biết</a:t>
+            </a:r>
+            <a:r>
               <a:rPr lang="en-US" sz="2100" dirty="0" spc="0" kern="0">
                 <a:solidFill>
                   <a:srgbClr val="C4C8D6"/>
@@ -15610,40 +15863,7 @@
                 <a:ea typeface="Be Vietnam Pro" pitchFamily="34" charset="-122"/>
                 <a:cs typeface="Be Vietnam Pro" pitchFamily="34" charset="-120"/>
               </a:rPr>
-              <a:t>Đó</a:t>
-            </a:r>
-            <a:r>
-              <a:rPr lang="en-US" sz="2100" dirty="0" spc="-4" kern="0">
-                <a:solidFill>
-                  <a:srgbClr val="C4C8D6"/>
-                </a:solidFill>
-                <a:latin typeface="Be Vietnam Pro" pitchFamily="34" charset="0"/>
-                <a:ea typeface="Be Vietnam Pro" pitchFamily="34" charset="-122"/>
-                <a:cs typeface="Be Vietnam Pro" pitchFamily="34" charset="-120"/>
-              </a:rPr>
-              <a:t> là</a:t>
-            </a:r>
-            <a:r>
-              <a:rPr lang="en-US" sz="2100" dirty="0" spc="-5" kern="0">
-                <a:solidFill>
-                  <a:srgbClr val="C4C8D6"/>
-                </a:solidFill>
-                <a:latin typeface="Be Vietnam Pro" pitchFamily="34" charset="0"/>
-                <a:ea typeface="Be Vietnam Pro" pitchFamily="34" charset="-122"/>
-                <a:cs typeface="Be Vietnam Pro" pitchFamily="34" charset="-120"/>
-              </a:rPr>
-              <a:t> Code</a:t>
-            </a:r>
-            <a:r>
-              <a:rPr lang="en-US" sz="2100" dirty="0" spc="-8" kern="0">
-                <a:solidFill>
-                  <a:srgbClr val="C4C8D6"/>
-                </a:solidFill>
-                <a:latin typeface="Be Vietnam Pro" pitchFamily="34" charset="0"/>
-                <a:ea typeface="Be Vietnam Pro" pitchFamily="34" charset="-122"/>
-                <a:cs typeface="Be Vietnam Pro" pitchFamily="34" charset="-120"/>
-              </a:rPr>
-              <a:t> Complete.</a:t>
+              <a:t> chung.</a:t>
             </a:r>
             <a:endParaRPr lang="en-US" sz="2100" dirty="0"/>
           </a:p>
@@ -16089,6 +16309,39 @@
               <a:buNone/>
             </a:pPr>
             <a:r>
+              <a:rPr lang="en-US" sz="2100" dirty="0" spc="2" kern="0">
+                <a:solidFill>
+                  <a:srgbClr val="C4C8D6"/>
+                </a:solidFill>
+                <a:latin typeface="Be Vietnam Pro" pitchFamily="34" charset="0"/>
+                <a:ea typeface="Be Vietnam Pro" pitchFamily="34" charset="-122"/>
+                <a:cs typeface="Be Vietnam Pro" pitchFamily="34" charset="-120"/>
+              </a:rPr>
+              <a:t>Chỉ</a:t>
+            </a:r>
+            <a:r>
+              <a:rPr lang="en-US" sz="2100" dirty="0" spc="-10" kern="0">
+                <a:solidFill>
+                  <a:srgbClr val="C4C8D6"/>
+                </a:solidFill>
+                <a:latin typeface="Be Vietnam Pro" pitchFamily="34" charset="0"/>
+                <a:ea typeface="Be Vietnam Pro" pitchFamily="34" charset="-122"/>
+                <a:cs typeface="Be Vietnam Pro" pitchFamily="34" charset="-120"/>
+              </a:rPr>
+              <a:t> lấy</a:t>
+            </a:r>
+            <a:r>
+              <a:rPr lang="en-US" sz="2100" dirty="0" spc="-11" kern="0">
+                <a:solidFill>
+                  <a:srgbClr val="C4C8D6"/>
+                </a:solidFill>
+                <a:latin typeface="Be Vietnam Pro" pitchFamily="34" charset="0"/>
+                <a:ea typeface="Be Vietnam Pro" pitchFamily="34" charset="-122"/>
+                <a:cs typeface="Be Vietnam Pro" pitchFamily="34" charset="-120"/>
+              </a:rPr>
+              <a:t> tên</a:t>
+            </a:r>
+            <a:r>
               <a:rPr lang="en-US" sz="2100" dirty="0" spc="-1" kern="0">
                 <a:solidFill>
                   <a:srgbClr val="C4C8D6"/>
@@ -16097,10 +16350,10 @@
                 <a:ea typeface="Be Vietnam Pro" pitchFamily="34" charset="-122"/>
                 <a:cs typeface="Be Vietnam Pro" pitchFamily="34" charset="-120"/>
               </a:rPr>
-              <a:t>Năm</a:t>
-            </a:r>
-            <a:r>
-              <a:rPr lang="en-US" sz="2100" dirty="0" spc="-2" kern="0">
+              <a:t> nhóm,</a:t>
+            </a:r>
+            <a:r>
+              <a:rPr lang="en-US" sz="2100" dirty="0" spc="-10" kern="0">
                 <a:solidFill>
                   <a:srgbClr val="C4C8D6"/>
                 </a:solidFill>
@@ -16108,10 +16361,10 @@
                 <a:ea typeface="Be Vietnam Pro" pitchFamily="34" charset="-122"/>
                 <a:cs typeface="Be Vietnam Pro" pitchFamily="34" charset="-120"/>
               </a:rPr>
-              <a:t> nhóm,</a:t>
-            </a:r>
-            <a:r>
-              <a:rPr lang="en-US" sz="2100" dirty="0" spc="5" kern="0">
+              <a:t> tên</a:t>
+            </a:r>
+            <a:r>
+              <a:rPr lang="en-US" sz="2100" dirty="0" spc="-5" kern="0">
                 <a:solidFill>
                   <a:srgbClr val="C4C8D6"/>
                 </a:solidFill>
@@ -16119,7 +16372,29 @@
                 <a:ea typeface="Be Vietnam Pro" pitchFamily="34" charset="-122"/>
                 <a:cs typeface="Be Vietnam Pro" pitchFamily="34" charset="-120"/>
               </a:rPr>
-              <a:t> mười</a:t>
+              <a:t> sách</a:t>
+            </a:r>
+            <a:r>
+              <a:rPr lang="en-US" sz="2100" dirty="0" spc="-18" kern="0">
+                <a:solidFill>
+                  <a:srgbClr val="C4C8D6"/>
+                </a:solidFill>
+                <a:latin typeface="Be Vietnam Pro" pitchFamily="34" charset="0"/>
+                <a:ea typeface="Be Vietnam Pro" pitchFamily="34" charset="-122"/>
+                <a:cs typeface="Be Vietnam Pro" pitchFamily="34" charset="-120"/>
+              </a:rPr>
+              <a:t> và</a:t>
+            </a:r>
+            <a:r>
+              <a:rPr lang="en-US" sz="2100" dirty="0" spc="-13" kern="0">
+                <a:solidFill>
+                  <a:srgbClr val="C4C8D6"/>
+                </a:solidFill>
+                <a:latin typeface="Be Vietnam Pro" pitchFamily="34" charset="0"/>
+                <a:ea typeface="Be Vietnam Pro" pitchFamily="34" charset="-122"/>
+                <a:cs typeface="Be Vietnam Pro" pitchFamily="34" charset="-120"/>
+              </a:rPr>
+              <a:t> tác</a:t>
             </a:r>
             <a:r>
               <a:rPr lang="en-US" sz="2100" dirty="0" spc="-1" kern="0">
@@ -16130,76 +16405,10 @@
                 <a:ea typeface="Be Vietnam Pro" pitchFamily="34" charset="-122"/>
                 <a:cs typeface="Be Vietnam Pro" pitchFamily="34" charset="-120"/>
               </a:rPr>
-              <a:t> cuốn,</a:t>
-            </a:r>
-            <a:r>
-              <a:rPr lang="en-US" sz="2100" dirty="0" spc="-2" kern="0">
-                <a:solidFill>
-                  <a:srgbClr val="C4C8D6"/>
-                </a:solidFill>
-                <a:latin typeface="Be Vietnam Pro" pitchFamily="34" charset="0"/>
-                <a:ea typeface="Be Vietnam Pro" pitchFamily="34" charset="-122"/>
-                <a:cs typeface="Be Vietnam Pro" pitchFamily="34" charset="-120"/>
-              </a:rPr>
-              <a:t> lời</a:t>
-            </a:r>
-            <a:r>
-              <a:rPr lang="en-US" sz="2100" dirty="0" spc="-3" kern="0">
-                <a:solidFill>
-                  <a:srgbClr val="C4C8D6"/>
-                </a:solidFill>
-                <a:latin typeface="Be Vietnam Pro" pitchFamily="34" charset="0"/>
-                <a:ea typeface="Be Vietnam Pro" pitchFamily="34" charset="-122"/>
-                <a:cs typeface="Be Vietnam Pro" pitchFamily="34" charset="-120"/>
-              </a:rPr>
-              <a:t> mô</a:t>
-            </a:r>
-            <a:r>
-              <a:rPr lang="en-US" sz="2100" dirty="0" spc="-18" kern="0">
-                <a:solidFill>
-                  <a:srgbClr val="C4C8D6"/>
-                </a:solidFill>
-                <a:latin typeface="Be Vietnam Pro" pitchFamily="34" charset="0"/>
-                <a:ea typeface="Be Vietnam Pro" pitchFamily="34" charset="-122"/>
-                <a:cs typeface="Be Vietnam Pro" pitchFamily="34" charset="-120"/>
-              </a:rPr>
-              <a:t> tả</a:t>
+              <a:t> giả.</a:t>
             </a:r>
             <a:r>
               <a:rPr lang="en-US" sz="2100" dirty="0" spc="0" kern="0">
-                <a:solidFill>
-                  <a:srgbClr val="C4C8D6"/>
-                </a:solidFill>
-                <a:latin typeface="Be Vietnam Pro" pitchFamily="34" charset="0"/>
-                <a:ea typeface="Be Vietnam Pro" pitchFamily="34" charset="-122"/>
-                <a:cs typeface="Be Vietnam Pro" pitchFamily="34" charset="-120"/>
-              </a:rPr>
-              <a:t> của</a:t>
-            </a:r>
-            <a:r>
-              <a:rPr lang="en-US" sz="2100" dirty="0" spc="-5" kern="0">
-                <a:solidFill>
-                  <a:srgbClr val="C4C8D6"/>
-                </a:solidFill>
-                <a:latin typeface="Be Vietnam Pro" pitchFamily="34" charset="0"/>
-                <a:ea typeface="Be Vietnam Pro" pitchFamily="34" charset="-122"/>
-                <a:cs typeface="Be Vietnam Pro" pitchFamily="34" charset="-120"/>
-              </a:rPr>
-              <a:t> Code</a:t>
-            </a:r>
-            <a:r>
-              <a:rPr lang="en-US" sz="2100" dirty="0" spc="-9" kern="0">
-                <a:solidFill>
-                  <a:srgbClr val="C4C8D6"/>
-                </a:solidFill>
-                <a:latin typeface="Be Vietnam Pro" pitchFamily="34" charset="0"/>
-                <a:ea typeface="Be Vietnam Pro" pitchFamily="34" charset="-122"/>
-                <a:cs typeface="Be Vietnam Pro" pitchFamily="34" charset="-120"/>
-              </a:rPr>
-              <a:t> Complete.</a:t>
-            </a:r>
-            <a:r>
-              <a:rPr lang="en-US" sz="2100" dirty="0" spc="1" kern="0">
                 <a:solidFill>
                   <a:srgbClr val="C4C8D6"/>
                 </a:solidFill>
@@ -16326,6 +16535,50 @@
               <a:t> ngày</a:t>
             </a:r>
             <a:r>
+              <a:rPr lang="en-US" sz="2100" dirty="0" spc="0" kern="0">
+                <a:solidFill>
+                  <a:srgbClr val="C4C8D6"/>
+                </a:solidFill>
+                <a:latin typeface="Be Vietnam Pro" pitchFamily="34" charset="0"/>
+                <a:ea typeface="Be Vietnam Pro" pitchFamily="34" charset="-122"/>
+                <a:cs typeface="Be Vietnam Pro" pitchFamily="34" charset="-120"/>
+              </a:rPr>
+              <a:t> 2026-10-19.</a:t>
+            </a:r>
+            <a:r>
+              <a:rPr lang="en-US" sz="2100" dirty="0" spc="-4" kern="0">
+                <a:solidFill>
+                  <a:srgbClr val="C4C8D6"/>
+                </a:solidFill>
+                <a:latin typeface="Be Vietnam Pro" pitchFamily="34" charset="0"/>
+                <a:ea typeface="Be Vietnam Pro" pitchFamily="34" charset="-122"/>
+                <a:cs typeface="Be Vietnam Pro" pitchFamily="34" charset="-120"/>
+              </a:rPr>
+              <a:t> Mô</a:t>
+            </a:r>
+            <a:r>
+              <a:rPr lang="en-US" sz="2100" dirty="0" spc="-17" kern="0">
+                <a:solidFill>
+                  <a:srgbClr val="C4C8D6"/>
+                </a:solidFill>
+                <a:latin typeface="Be Vietnam Pro" pitchFamily="34" charset="0"/>
+                <a:ea typeface="Be Vietnam Pro" pitchFamily="34" charset="-122"/>
+                <a:cs typeface="Be Vietnam Pro" pitchFamily="34" charset="-120"/>
+              </a:rPr>
+              <a:t> tả</a:t>
+            </a:r>
+            <a:r>
+              <a:rPr lang="en-US" sz="2100" dirty="0" spc="17" kern="0">
+                <a:solidFill>
+                  <a:srgbClr val="C4C8D6"/>
+                </a:solidFill>
+                <a:latin typeface="Be Vietnam Pro" pitchFamily="34" charset="0"/>
+                <a:ea typeface="Be Vietnam Pro" pitchFamily="34" charset="-122"/>
+                <a:cs typeface="Be Vietnam Pro" pitchFamily="34" charset="-120"/>
+              </a:rPr>
+              <a:t> từng</a:t>
+            </a:r>
+            <a:r>
               <a:rPr lang="en-US" sz="2100" dirty="0" spc="-1" kern="0">
                 <a:solidFill>
                   <a:srgbClr val="C4C8D6"/>
@@ -16334,10 +16587,10 @@
                 <a:ea typeface="Be Vietnam Pro" pitchFamily="34" charset="-122"/>
                 <a:cs typeface="Be Vietnam Pro" pitchFamily="34" charset="-120"/>
               </a:rPr>
-              <a:t> 2026-10-18.</a:t>
-            </a:r>
-            <a:r>
-              <a:rPr lang="en-US" sz="2100" dirty="0" spc="0" kern="0">
+              <a:t> cuốn</a:t>
+            </a:r>
+            <a:r>
+              <a:rPr lang="en-US" sz="2100" dirty="0" spc="4" kern="0">
                 <a:solidFill>
                   <a:srgbClr val="C4C8D6"/>
                 </a:solidFill>
@@ -16345,7 +16598,18 @@
                 <a:ea typeface="Be Vietnam Pro" pitchFamily="34" charset="-122"/>
                 <a:cs typeface="Be Vietnam Pro" pitchFamily="34" charset="-120"/>
               </a:rPr>
-              <a:t> Hình</a:t>
+              <a:t> chưa</a:t>
+            </a:r>
+            <a:r>
+              <a:rPr lang="en-US" sz="2100" dirty="0" spc="10" kern="0">
+                <a:solidFill>
+                  <a:srgbClr val="C4C8D6"/>
+                </a:solidFill>
+                <a:latin typeface="Be Vietnam Pro" pitchFamily="34" charset="0"/>
+                <a:ea typeface="Be Vietnam Pro" pitchFamily="34" charset="-122"/>
+                <a:cs typeface="Be Vietnam Pro" pitchFamily="34" charset="-120"/>
+              </a:rPr>
+              <a:t> đối</a:t>
             </a:r>
             <a:r>
               <a:rPr lang="en-US" sz="2100" dirty="0" spc="1" kern="0">
@@ -16356,10 +16620,10 @@
                 <a:ea typeface="Be Vietnam Pro" pitchFamily="34" charset="-122"/>
                 <a:cs typeface="Be Vietnam Pro" pitchFamily="34" charset="-120"/>
               </a:rPr>
-              <a:t> minh</a:t>
-            </a:r>
-            <a:r>
-              <a:rPr lang="en-US" sz="2100" dirty="0" spc="-6" kern="0">
+              <a:t> chiếu</a:t>
+            </a:r>
+            <a:r>
+              <a:rPr lang="en-US" sz="2100" dirty="0" spc="-15" kern="0">
                 <a:solidFill>
                   <a:srgbClr val="C4C8D6"/>
                 </a:solidFill>
@@ -16367,10 +16631,10 @@
                 <a:ea typeface="Be Vietnam Pro" pitchFamily="34" charset="-122"/>
                 <a:cs typeface="Be Vietnam Pro" pitchFamily="34" charset="-120"/>
               </a:rPr>
-              <a:t> họa</a:t>
-            </a:r>
-            <a:r>
-              <a:rPr lang="en-US" sz="2100" dirty="0" spc="-3" kern="0">
+              <a:t> trang</a:t>
+            </a:r>
+            <a:r>
+              <a:rPr lang="en-US" sz="2100" dirty="0" spc="-2" kern="0">
                 <a:solidFill>
                   <a:srgbClr val="C4C8D6"/>
                 </a:solidFill>
@@ -16378,7 +16642,18 @@
                 <a:ea typeface="Be Vietnam Pro" pitchFamily="34" charset="-122"/>
                 <a:cs typeface="Be Vietnam Pro" pitchFamily="34" charset="-120"/>
               </a:rPr>
-              <a:t> là</a:t>
+              <a:t> nhà</a:t>
+            </a:r>
+            <a:r>
+              <a:rPr lang="en-US" sz="2100" dirty="0" spc="-10" kern="0">
+                <a:solidFill>
+                  <a:srgbClr val="C4C8D6"/>
+                </a:solidFill>
+                <a:latin typeface="Be Vietnam Pro" pitchFamily="34" charset="0"/>
+                <a:ea typeface="Be Vietnam Pro" pitchFamily="34" charset="-122"/>
+                <a:cs typeface="Be Vietnam Pro" pitchFamily="34" charset="-120"/>
+              </a:rPr>
+              <a:t> xuất</a:t>
             </a:r>
             <a:r>
               <a:rPr lang="en-US" sz="2100" dirty="0" spc="-4" kern="0">
@@ -16389,29 +16664,7 @@
                 <a:ea typeface="Be Vietnam Pro" pitchFamily="34" charset="-122"/>
                 <a:cs typeface="Be Vietnam Pro" pitchFamily="34" charset="-120"/>
               </a:rPr>
-              <a:t> thiết</a:t>
-            </a:r>
-            <a:r>
-              <a:rPr lang="en-US" sz="2100" dirty="0" spc="-30" kern="0">
-                <a:solidFill>
-                  <a:srgbClr val="C4C8D6"/>
-                </a:solidFill>
-                <a:latin typeface="Be Vietnam Pro" pitchFamily="34" charset="0"/>
-                <a:ea typeface="Be Vietnam Pro" pitchFamily="34" charset="-122"/>
-                <a:cs typeface="Be Vietnam Pro" pitchFamily="34" charset="-120"/>
-              </a:rPr>
-              <a:t> kế</a:t>
-            </a:r>
-            <a:r>
-              <a:rPr lang="en-US" sz="2100" dirty="0" spc="-1" kern="0">
-                <a:solidFill>
-                  <a:srgbClr val="C4C8D6"/>
-                </a:solidFill>
-                <a:latin typeface="Be Vietnam Pro" pitchFamily="34" charset="0"/>
-                <a:ea typeface="Be Vietnam Pro" pitchFamily="34" charset="-122"/>
-                <a:cs typeface="Be Vietnam Pro" pitchFamily="34" charset="-120"/>
-              </a:rPr>
-              <a:t> mới.</a:t>
+              <a:t> bản.</a:t>
             </a:r>
             <a:endParaRPr lang="en-US" sz="2100" dirty="0"/>
           </a:p>

</xml_diff>